<commit_message>
Update SMB bundles deliverables
</commit_message>
<xml_diff>
--- a/deliverables/smb_bundles/assignment_2_q1_only.pptx
+++ b/deliverables/smb_bundles/assignment_2_q1_only.pptx
@@ -2408,7 +2408,7 @@
 </file>
 
 <file path=ppt/slides/slide2.xml><?xml version="1.0" encoding="utf-8"?>
-<p:sld xmlns:a="http://schemas.openxmlformats.org/drawingml/2006/main" xmlns:r="http://schemas.openxmlformats.org/officeDocument/2006/relationships" xmlns:p="http://schemas.openxmlformats.org/presentationml/2006/main">
+<p:sld xmlns:a="http://schemas.openxmlformats.org/drawingml/2006/main" xmlns:ns2="http://schemas.microsoft.com/office/drawing/2014/main" xmlns:ns3="http://schemas.microsoft.com/office/powerpoint/2010/main" xmlns:p="http://schemas.openxmlformats.org/presentationml/2006/main">
   <p:cSld>
     <p:bg>
       <p:bgPr>
@@ -2437,7 +2437,7 @@
           <p:cNvPr id="2" name="Text">
             <a:extLst>
               <a:ext uri="{FF2B5EF4-FFF2-40B4-BE49-F238E27FC236}">
-                <a16:creationId xmlns:a16="http://schemas.microsoft.com/office/drawing/2014/main" id="{18E998B9-F88E-4699-A13C-0F116878D7DE}"/>
+                <ns2:creationId id="{18E998B9-F88E-4699-A13C-0F116878D7DE}"/>
               </a:ext>
             </a:extLst>
           </p:cNvPr>
@@ -2496,7 +2496,7 @@
           <p:cNvPr id="3" name="Text">
             <a:extLst>
               <a:ext uri="{FF2B5EF4-FFF2-40B4-BE49-F238E27FC236}">
-                <a16:creationId xmlns:a16="http://schemas.microsoft.com/office/drawing/2014/main" id="{0518099F-4F90-437E-8EBF-7E40973988EF}"/>
+                <ns2:creationId id="{0518099F-4F90-437E-8EBF-7E40973988EF}"/>
               </a:ext>
             </a:extLst>
           </p:cNvPr>
@@ -2555,7 +2555,7 @@
           <p:cNvPr id="4" name="Divider">
             <a:extLst>
               <a:ext uri="{FF2B5EF4-FFF2-40B4-BE49-F238E27FC236}">
-                <a16:creationId xmlns:a16="http://schemas.microsoft.com/office/drawing/2014/main" id="{CC4322F5-8965-4F7E-88FF-C8024590E0E5}"/>
+                <ns2:creationId id="{CC4322F5-8965-4F7E-88FF-C8024590E0E5}"/>
               </a:ext>
             </a:extLst>
           </p:cNvPr>
@@ -2591,7 +2591,7 @@
           <p:cNvPr id="6" name="Divider">
             <a:extLst>
               <a:ext uri="{FF2B5EF4-FFF2-40B4-BE49-F238E27FC236}">
-                <a16:creationId xmlns:a16="http://schemas.microsoft.com/office/drawing/2014/main" id="{AEADAF99-75EE-4B6D-9374-F558920C9DF2}"/>
+                <ns2:creationId id="{AEADAF99-75EE-4B6D-9374-F558920C9DF2}"/>
               </a:ext>
             </a:extLst>
           </p:cNvPr>
@@ -2627,7 +2627,7 @@
           <p:cNvPr id="7" name="Text">
             <a:extLst>
               <a:ext uri="{FF2B5EF4-FFF2-40B4-BE49-F238E27FC236}">
-                <a16:creationId xmlns:a16="http://schemas.microsoft.com/office/drawing/2014/main" id="{70C0DF54-E1E1-4B31-AE44-37C300A4C506}"/>
+                <ns2:creationId id="{70C0DF54-E1E1-4B31-AE44-37C300A4C506}"/>
               </a:ext>
             </a:extLst>
           </p:cNvPr>
@@ -2686,7 +2686,7 @@
           <p:cNvPr id="8" name="Text">
             <a:extLst>
               <a:ext uri="{FF2B5EF4-FFF2-40B4-BE49-F238E27FC236}">
-                <a16:creationId xmlns:a16="http://schemas.microsoft.com/office/drawing/2014/main" id="{AB90A983-65B5-4926-8687-4CC0E482D0D9}"/>
+                <ns2:creationId id="{AB90A983-65B5-4926-8687-4CC0E482D0D9}"/>
               </a:ext>
             </a:extLst>
           </p:cNvPr>
@@ -2745,7 +2745,7 @@
           <p:cNvPr id="9" name="Framing intro">
             <a:extLst>
               <a:ext uri="{FF2B5EF4-FFF2-40B4-BE49-F238E27FC236}">
-                <a16:creationId xmlns:a16="http://schemas.microsoft.com/office/drawing/2014/main" id="{9193F9C6-41EE-4080-99E5-19D607DB5747}"/>
+                <ns2:creationId id="{9193F9C6-41EE-4080-99E5-19D607DB5747}"/>
               </a:ext>
             </a:extLst>
           </p:cNvPr>
@@ -2789,7 +2789,7 @@
           <p:cNvPr id="10" name="Signal Map label">
             <a:extLst>
               <a:ext uri="{FF2B5EF4-FFF2-40B4-BE49-F238E27FC236}">
-                <a16:creationId xmlns:a16="http://schemas.microsoft.com/office/drawing/2014/main" id="{2178FA77-A0E9-4651-8A84-AC52DF717621}"/>
+                <ns2:creationId id="{2178FA77-A0E9-4651-8A84-AC52DF717621}"/>
               </a:ext>
             </a:extLst>
           </p:cNvPr>
@@ -2833,7 +2833,7 @@
           <p:cNvPr id="11" name="Business Setup card">
             <a:extLst>
               <a:ext uri="{FF2B5EF4-FFF2-40B4-BE49-F238E27FC236}">
-                <a16:creationId xmlns:a16="http://schemas.microsoft.com/office/drawing/2014/main" id="{C7FFC7DF-4E61-4CE4-A6F2-33430D7E3FA1}"/>
+                <ns2:creationId id="{C7FFC7DF-4E61-4CE4-A6F2-33430D7E3FA1}"/>
               </a:ext>
             </a:extLst>
           </p:cNvPr>
@@ -2872,7 +2872,7 @@
           <p:cNvPr id="12" name="Business Setup accent">
             <a:extLst>
               <a:ext uri="{FF2B5EF4-FFF2-40B4-BE49-F238E27FC236}">
-                <a16:creationId xmlns:a16="http://schemas.microsoft.com/office/drawing/2014/main" id="{8F8E834F-FE5B-4DC9-8932-DFDC03636BDE}"/>
+                <ns2:creationId id="{8F8E834F-FE5B-4DC9-8932-DFDC03636BDE}"/>
               </a:ext>
             </a:extLst>
           </p:cNvPr>
@@ -2914,7 +2914,7 @@
           <p:cNvPr id="13" name="Business Setup title">
             <a:extLst>
               <a:ext uri="{FF2B5EF4-FFF2-40B4-BE49-F238E27FC236}">
-                <a16:creationId xmlns:a16="http://schemas.microsoft.com/office/drawing/2014/main" id="{7D9E8E70-5B22-4E93-9701-BDB2FB316955}"/>
+                <ns2:creationId id="{7D9E8E70-5B22-4E93-9701-BDB2FB316955}"/>
               </a:ext>
             </a:extLst>
           </p:cNvPr>
@@ -2969,7 +2969,7 @@
           <p:cNvPr id="14" name="Signal bullet">
             <a:extLst>
               <a:ext uri="{FF2B5EF4-FFF2-40B4-BE49-F238E27FC236}">
-                <a16:creationId xmlns:a16="http://schemas.microsoft.com/office/drawing/2014/main" id="{7B56A51E-5F3E-422F-80C4-58E8EE88FB23}"/>
+                <ns2:creationId id="{7B56A51E-5F3E-422F-80C4-58E8EE88FB23}"/>
               </a:ext>
             </a:extLst>
           </p:cNvPr>
@@ -3006,7 +3006,7 @@
           <p:cNvPr id="15" name="Business Setup item">
             <a:extLst>
               <a:ext uri="{FF2B5EF4-FFF2-40B4-BE49-F238E27FC236}">
-                <a16:creationId xmlns:a16="http://schemas.microsoft.com/office/drawing/2014/main" id="{B4FC3418-FD5C-45BD-AC2C-BC074CB59259}"/>
+                <ns2:creationId id="{B4FC3418-FD5C-45BD-AC2C-BC074CB59259}"/>
               </a:ext>
             </a:extLst>
           </p:cNvPr>
@@ -3050,7 +3050,7 @@
           <p:cNvPr id="16" name="Signal bullet">
             <a:extLst>
               <a:ext uri="{FF2B5EF4-FFF2-40B4-BE49-F238E27FC236}">
-                <a16:creationId xmlns:a16="http://schemas.microsoft.com/office/drawing/2014/main" id="{B14A1CE9-D141-4F64-A7EF-D4B4BF92A59E}"/>
+                <ns2:creationId id="{B14A1CE9-D141-4F64-A7EF-D4B4BF92A59E}"/>
               </a:ext>
             </a:extLst>
           </p:cNvPr>
@@ -3087,7 +3087,7 @@
           <p:cNvPr id="17" name="Business Setup item">
             <a:extLst>
               <a:ext uri="{FF2B5EF4-FFF2-40B4-BE49-F238E27FC236}">
-                <a16:creationId xmlns:a16="http://schemas.microsoft.com/office/drawing/2014/main" id="{B469ED38-7D8B-4DE8-9700-530B606571D5}"/>
+                <ns2:creationId id="{B469ED38-7D8B-4DE8-9700-530B606571D5}"/>
               </a:ext>
             </a:extLst>
           </p:cNvPr>
@@ -3131,7 +3131,7 @@
           <p:cNvPr id="18" name="Paid Usage card">
             <a:extLst>
               <a:ext uri="{FF2B5EF4-FFF2-40B4-BE49-F238E27FC236}">
-                <a16:creationId xmlns:a16="http://schemas.microsoft.com/office/drawing/2014/main" id="{A9DCA840-A6C9-4825-B340-E7CC272C1A10}"/>
+                <ns2:creationId id="{A9DCA840-A6C9-4825-B340-E7CC272C1A10}"/>
               </a:ext>
             </a:extLst>
           </p:cNvPr>
@@ -3170,7 +3170,7 @@
           <p:cNvPr id="19" name="Paid Usage accent">
             <a:extLst>
               <a:ext uri="{FF2B5EF4-FFF2-40B4-BE49-F238E27FC236}">
-                <a16:creationId xmlns:a16="http://schemas.microsoft.com/office/drawing/2014/main" id="{222202EB-5AE5-42B9-82C0-54215292C2FF}"/>
+                <ns2:creationId id="{222202EB-5AE5-42B9-82C0-54215292C2FF}"/>
               </a:ext>
             </a:extLst>
           </p:cNvPr>
@@ -3209,7 +3209,7 @@
           <p:cNvPr id="20" name="Paid Usage title">
             <a:extLst>
               <a:ext uri="{FF2B5EF4-FFF2-40B4-BE49-F238E27FC236}">
-                <a16:creationId xmlns:a16="http://schemas.microsoft.com/office/drawing/2014/main" id="{72DD9E6A-2D90-447E-9783-0FC7A11F6365}"/>
+                <ns2:creationId id="{72DD9E6A-2D90-447E-9783-0FC7A11F6365}"/>
               </a:ext>
             </a:extLst>
           </p:cNvPr>
@@ -3264,7 +3264,7 @@
           <p:cNvPr id="21" name="Signal bullet">
             <a:extLst>
               <a:ext uri="{FF2B5EF4-FFF2-40B4-BE49-F238E27FC236}">
-                <a16:creationId xmlns:a16="http://schemas.microsoft.com/office/drawing/2014/main" id="{CA725DE6-45B1-4EFE-B3C9-EF75F8B52A9A}"/>
+                <ns2:creationId id="{CA725DE6-45B1-4EFE-B3C9-EF75F8B52A9A}"/>
               </a:ext>
             </a:extLst>
           </p:cNvPr>
@@ -3301,7 +3301,7 @@
           <p:cNvPr id="22" name="Paid Usage item">
             <a:extLst>
               <a:ext uri="{FF2B5EF4-FFF2-40B4-BE49-F238E27FC236}">
-                <a16:creationId xmlns:a16="http://schemas.microsoft.com/office/drawing/2014/main" id="{0675CBDE-5BDB-4CA7-ABBF-BA7C7327CCA2}"/>
+                <ns2:creationId id="{0675CBDE-5BDB-4CA7-ABBF-BA7C7327CCA2}"/>
               </a:ext>
             </a:extLst>
           </p:cNvPr>
@@ -3345,7 +3345,7 @@
           <p:cNvPr id="23" name="Signal bullet">
             <a:extLst>
               <a:ext uri="{FF2B5EF4-FFF2-40B4-BE49-F238E27FC236}">
-                <a16:creationId xmlns:a16="http://schemas.microsoft.com/office/drawing/2014/main" id="{21856CE8-A264-4587-95B3-029FD2FBDEDD}"/>
+                <ns2:creationId id="{21856CE8-A264-4587-95B3-029FD2FBDEDD}"/>
               </a:ext>
             </a:extLst>
           </p:cNvPr>
@@ -3382,7 +3382,7 @@
           <p:cNvPr id="24" name="Paid Usage item">
             <a:extLst>
               <a:ext uri="{FF2B5EF4-FFF2-40B4-BE49-F238E27FC236}">
-                <a16:creationId xmlns:a16="http://schemas.microsoft.com/office/drawing/2014/main" id="{77ECC5B7-96DB-4BA4-BF5D-832D68C65387}"/>
+                <ns2:creationId id="{77ECC5B7-96DB-4BA4-BF5D-832D68C65387}"/>
               </a:ext>
             </a:extLst>
           </p:cNvPr>
@@ -3426,7 +3426,7 @@
           <p:cNvPr id="25" name="Seller Activity card">
             <a:extLst>
               <a:ext uri="{FF2B5EF4-FFF2-40B4-BE49-F238E27FC236}">
-                <a16:creationId xmlns:a16="http://schemas.microsoft.com/office/drawing/2014/main" id="{7987C853-D92F-4CCE-9116-518E7F87387D}"/>
+                <ns2:creationId id="{7987C853-D92F-4CCE-9116-518E7F87387D}"/>
               </a:ext>
             </a:extLst>
           </p:cNvPr>
@@ -3465,7 +3465,7 @@
           <p:cNvPr id="26" name="Seller Activity accent">
             <a:extLst>
               <a:ext uri="{FF2B5EF4-FFF2-40B4-BE49-F238E27FC236}">
-                <a16:creationId xmlns:a16="http://schemas.microsoft.com/office/drawing/2014/main" id="{3687BD4C-7470-40F1-98B1-0268824BAB61}"/>
+                <ns2:creationId id="{3687BD4C-7470-40F1-98B1-0268824BAB61}"/>
               </a:ext>
             </a:extLst>
           </p:cNvPr>
@@ -3504,7 +3504,7 @@
           <p:cNvPr id="27" name="Seller Activity title">
             <a:extLst>
               <a:ext uri="{FF2B5EF4-FFF2-40B4-BE49-F238E27FC236}">
-                <a16:creationId xmlns:a16="http://schemas.microsoft.com/office/drawing/2014/main" id="{FFDD1A22-E70D-454D-8D01-B7C064F06203}"/>
+                <ns2:creationId id="{FFDD1A22-E70D-454D-8D01-B7C064F06203}"/>
               </a:ext>
             </a:extLst>
           </p:cNvPr>
@@ -3548,7 +3548,7 @@
           <p:cNvPr id="28" name="Signal bullet">
             <a:extLst>
               <a:ext uri="{FF2B5EF4-FFF2-40B4-BE49-F238E27FC236}">
-                <a16:creationId xmlns:a16="http://schemas.microsoft.com/office/drawing/2014/main" id="{144F21A3-D738-452D-AAE6-160D2E809261}"/>
+                <ns2:creationId id="{144F21A3-D738-452D-AAE6-160D2E809261}"/>
               </a:ext>
             </a:extLst>
           </p:cNvPr>
@@ -3585,7 +3585,7 @@
           <p:cNvPr id="29" name="Seller Activity item">
             <a:extLst>
               <a:ext uri="{FF2B5EF4-FFF2-40B4-BE49-F238E27FC236}">
-                <a16:creationId xmlns:a16="http://schemas.microsoft.com/office/drawing/2014/main" id="{49F3CCD9-43DB-4DF4-9E52-3895C28C1A51}"/>
+                <ns2:creationId id="{49F3CCD9-43DB-4DF4-9E52-3895C28C1A51}"/>
               </a:ext>
             </a:extLst>
           </p:cNvPr>
@@ -3629,7 +3629,7 @@
           <p:cNvPr id="30" name="Signal bullet">
             <a:extLst>
               <a:ext uri="{FF2B5EF4-FFF2-40B4-BE49-F238E27FC236}">
-                <a16:creationId xmlns:a16="http://schemas.microsoft.com/office/drawing/2014/main" id="{8BC7A4E6-11F4-43B9-9D4F-3980FAEC70AE}"/>
+                <ns2:creationId id="{8BC7A4E6-11F4-43B9-9D4F-3980FAEC70AE}"/>
               </a:ext>
             </a:extLst>
           </p:cNvPr>
@@ -3666,7 +3666,7 @@
           <p:cNvPr id="31" name="Seller Activity item">
             <a:extLst>
               <a:ext uri="{FF2B5EF4-FFF2-40B4-BE49-F238E27FC236}">
-                <a16:creationId xmlns:a16="http://schemas.microsoft.com/office/drawing/2014/main" id="{0E9B555A-9C31-4082-A516-9A9DEA35A176}"/>
+                <ns2:creationId id="{0E9B555A-9C31-4082-A516-9A9DEA35A176}"/>
               </a:ext>
             </a:extLst>
           </p:cNvPr>
@@ -3710,7 +3710,7 @@
           <p:cNvPr id="32" name="Category Focus card">
             <a:extLst>
               <a:ext uri="{FF2B5EF4-FFF2-40B4-BE49-F238E27FC236}">
-                <a16:creationId xmlns:a16="http://schemas.microsoft.com/office/drawing/2014/main" id="{D71119D6-85B8-4430-A6E9-786092D0560B}"/>
+                <ns2:creationId id="{D71119D6-85B8-4430-A6E9-786092D0560B}"/>
               </a:ext>
             </a:extLst>
           </p:cNvPr>
@@ -3749,7 +3749,7 @@
           <p:cNvPr id="33" name="Category Focus accent">
             <a:extLst>
               <a:ext uri="{FF2B5EF4-FFF2-40B4-BE49-F238E27FC236}">
-                <a16:creationId xmlns:a16="http://schemas.microsoft.com/office/drawing/2014/main" id="{2E0A62FB-C9A0-4046-BEBC-07C6A8EEC3A6}"/>
+                <ns2:creationId id="{2E0A62FB-C9A0-4046-BEBC-07C6A8EEC3A6}"/>
               </a:ext>
             </a:extLst>
           </p:cNvPr>
@@ -3788,7 +3788,7 @@
           <p:cNvPr id="34" name="Category Focus title">
             <a:extLst>
               <a:ext uri="{FF2B5EF4-FFF2-40B4-BE49-F238E27FC236}">
-                <a16:creationId xmlns:a16="http://schemas.microsoft.com/office/drawing/2014/main" id="{928DC57C-FE56-4CCB-90DA-5D3CC59B5756}"/>
+                <ns2:creationId id="{928DC57C-FE56-4CCB-90DA-5D3CC59B5756}"/>
               </a:ext>
             </a:extLst>
           </p:cNvPr>
@@ -3843,7 +3843,7 @@
           <p:cNvPr id="35" name="Signal bullet">
             <a:extLst>
               <a:ext uri="{FF2B5EF4-FFF2-40B4-BE49-F238E27FC236}">
-                <a16:creationId xmlns:a16="http://schemas.microsoft.com/office/drawing/2014/main" id="{7A6351F8-4C68-48D0-B0B9-9D66CF8A3D68}"/>
+                <ns2:creationId id="{7A6351F8-4C68-48D0-B0B9-9D66CF8A3D68}"/>
               </a:ext>
             </a:extLst>
           </p:cNvPr>
@@ -3880,7 +3880,7 @@
           <p:cNvPr id="36" name="Category Focus item">
             <a:extLst>
               <a:ext uri="{FF2B5EF4-FFF2-40B4-BE49-F238E27FC236}">
-                <a16:creationId xmlns:a16="http://schemas.microsoft.com/office/drawing/2014/main" id="{B1A97181-513A-4A9F-A03F-DD5DB8ED741A}"/>
+                <ns2:creationId id="{B1A97181-513A-4A9F-A03F-DD5DB8ED741A}"/>
               </a:ext>
             </a:extLst>
           </p:cNvPr>
@@ -3914,7 +3914,7 @@
                 <a:ea typeface="Arial"/>
                 <a:cs typeface="Arial"/>
               </a:rPr>
-              <a:t>Repeated category use</a:t>
+              <a:t>Repeated category/subcategory</a:t>
             </a:r>
           </a:p>
         </p:txBody>
@@ -3924,7 +3924,7 @@
           <p:cNvPr id="37" name="Signal bullet">
             <a:extLst>
               <a:ext uri="{FF2B5EF4-FFF2-40B4-BE49-F238E27FC236}">
-                <a16:creationId xmlns:a16="http://schemas.microsoft.com/office/drawing/2014/main" id="{3BE1C13B-6D87-4F60-9FC9-A66B16638F60}"/>
+                <ns2:creationId id="{3BE1C13B-6D87-4F60-9FC9-A66B16638F60}"/>
               </a:ext>
             </a:extLst>
           </p:cNvPr>
@@ -3961,7 +3961,7 @@
           <p:cNvPr id="38" name="Category Focus item">
             <a:extLst>
               <a:ext uri="{FF2B5EF4-FFF2-40B4-BE49-F238E27FC236}">
-                <a16:creationId xmlns:a16="http://schemas.microsoft.com/office/drawing/2014/main" id="{0C6E2724-9D5D-4507-85DB-BC4B505BB9E6}"/>
+                <ns2:creationId id="{0C6E2724-9D5D-4507-85DB-BC4B505BB9E6}"/>
               </a:ext>
             </a:extLst>
           </p:cNvPr>
@@ -3995,7 +3995,7 @@
                 <a:ea typeface="Arial"/>
                 <a:cs typeface="Arial"/>
               </a:rPr>
-              <a:t>Business-prone categories</a:t>
+              <a:t>Category-specific thresholds</a:t>
             </a:r>
           </a:p>
         </p:txBody>
@@ -4005,7 +4005,7 @@
           <p:cNvPr id="39" name="Buyer Demand card">
             <a:extLst>
               <a:ext uri="{FF2B5EF4-FFF2-40B4-BE49-F238E27FC236}">
-                <a16:creationId xmlns:a16="http://schemas.microsoft.com/office/drawing/2014/main" id="{9664A2EA-0669-4FE7-831D-A0CC724AC0E5}"/>
+                <ns2:creationId id="{9664A2EA-0669-4FE7-831D-A0CC724AC0E5}"/>
               </a:ext>
             </a:extLst>
           </p:cNvPr>
@@ -4044,7 +4044,7 @@
           <p:cNvPr id="40" name="Buyer Demand accent">
             <a:extLst>
               <a:ext uri="{FF2B5EF4-FFF2-40B4-BE49-F238E27FC236}">
-                <a16:creationId xmlns:a16="http://schemas.microsoft.com/office/drawing/2014/main" id="{254B3EC9-675A-4691-AF61-ED63169A3219}"/>
+                <ns2:creationId id="{254B3EC9-675A-4691-AF61-ED63169A3219}"/>
               </a:ext>
             </a:extLst>
           </p:cNvPr>
@@ -4083,7 +4083,7 @@
           <p:cNvPr id="41" name="Buyer Demand title">
             <a:extLst>
               <a:ext uri="{FF2B5EF4-FFF2-40B4-BE49-F238E27FC236}">
-                <a16:creationId xmlns:a16="http://schemas.microsoft.com/office/drawing/2014/main" id="{F7C8B1E1-852F-4C6C-83A5-EB56C896C9E0}"/>
+                <ns2:creationId id="{F7C8B1E1-852F-4C6C-83A5-EB56C896C9E0}"/>
               </a:ext>
             </a:extLst>
           </p:cNvPr>
@@ -4138,7 +4138,7 @@
           <p:cNvPr id="42" name="Signal bullet">
             <a:extLst>
               <a:ext uri="{FF2B5EF4-FFF2-40B4-BE49-F238E27FC236}">
-                <a16:creationId xmlns:a16="http://schemas.microsoft.com/office/drawing/2014/main" id="{29AAEA38-388B-4218-AF99-760F3ACB07B3}"/>
+                <ns2:creationId id="{29AAEA38-388B-4218-AF99-760F3ACB07B3}"/>
               </a:ext>
             </a:extLst>
           </p:cNvPr>
@@ -4175,7 +4175,7 @@
           <p:cNvPr id="43" name="Buyer Demand item">
             <a:extLst>
               <a:ext uri="{FF2B5EF4-FFF2-40B4-BE49-F238E27FC236}">
-                <a16:creationId xmlns:a16="http://schemas.microsoft.com/office/drawing/2014/main" id="{6EF00164-93C6-4F9D-A165-828EA0E36D9A}"/>
+                <ns2:creationId id="{6EF00164-93C6-4F9D-A165-828EA0E36D9A}"/>
               </a:ext>
             </a:extLst>
           </p:cNvPr>
@@ -4219,7 +4219,7 @@
           <p:cNvPr id="44" name="Signal bullet">
             <a:extLst>
               <a:ext uri="{FF2B5EF4-FFF2-40B4-BE49-F238E27FC236}">
-                <a16:creationId xmlns:a16="http://schemas.microsoft.com/office/drawing/2014/main" id="{25757DBF-E54D-41B9-8864-36A3772C014F}"/>
+                <ns2:creationId id="{25757DBF-E54D-41B9-8864-36A3772C014F}"/>
               </a:ext>
             </a:extLst>
           </p:cNvPr>
@@ -4256,7 +4256,7 @@
           <p:cNvPr id="45" name="Buyer Demand item">
             <a:extLst>
               <a:ext uri="{FF2B5EF4-FFF2-40B4-BE49-F238E27FC236}">
-                <a16:creationId xmlns:a16="http://schemas.microsoft.com/office/drawing/2014/main" id="{C27D2C33-21D5-4658-8E6A-35747344CF5E}"/>
+                <ns2:creationId id="{C27D2C33-21D5-4658-8E6A-35747344CF5E}"/>
               </a:ext>
             </a:extLst>
           </p:cNvPr>
@@ -4300,7 +4300,7 @@
           <p:cNvPr id="46" name="Scoring Flow label">
             <a:extLst>
               <a:ext uri="{FF2B5EF4-FFF2-40B4-BE49-F238E27FC236}">
-                <a16:creationId xmlns:a16="http://schemas.microsoft.com/office/drawing/2014/main" id="{47D1F815-DDE6-4E60-B387-97C475589306}"/>
+                <ns2:creationId id="{47D1F815-DDE6-4E60-B387-97C475589306}"/>
               </a:ext>
             </a:extLst>
           </p:cNvPr>
@@ -4344,7 +4344,7 @@
           <p:cNvPr id="47" name="Raw seller data flow node">
             <a:extLst>
               <a:ext uri="{FF2B5EF4-FFF2-40B4-BE49-F238E27FC236}">
-                <a16:creationId xmlns:a16="http://schemas.microsoft.com/office/drawing/2014/main" id="{228E9DF1-5F1B-4E06-8A4C-6A9D6C33C93F}"/>
+                <ns2:creationId id="{228E9DF1-5F1B-4E06-8A4C-6A9D6C33C93F}"/>
               </a:ext>
             </a:extLst>
           </p:cNvPr>
@@ -4383,7 +4383,7 @@
           <p:cNvPr id="48" name="Raw seller data flow title">
             <a:extLst>
               <a:ext uri="{FF2B5EF4-FFF2-40B4-BE49-F238E27FC236}">
-                <a16:creationId xmlns:a16="http://schemas.microsoft.com/office/drawing/2014/main" id="{FF9E5EFA-46E4-483C-A6BB-AE380FEFF886}"/>
+                <ns2:creationId id="{FF9E5EFA-46E4-483C-A6BB-AE380FEFF886}"/>
               </a:ext>
             </a:extLst>
           </p:cNvPr>
@@ -4427,7 +4427,7 @@
           <p:cNvPr id="49" name="Raw seller data flow sub">
             <a:extLst>
               <a:ext uri="{FF2B5EF4-FFF2-40B4-BE49-F238E27FC236}">
-                <a16:creationId xmlns:a16="http://schemas.microsoft.com/office/drawing/2014/main" id="{02C0D121-F20E-4F14-94E4-E0106269114C}"/>
+                <ns2:creationId id="{02C0D121-F20E-4F14-94E4-E0106269114C}"/>
               </a:ext>
             </a:extLst>
           </p:cNvPr>
@@ -4471,7 +4471,7 @@
           <p:cNvPr id="50" name="Scoring flow arrow">
             <a:extLst>
               <a:ext uri="{FF2B5EF4-FFF2-40B4-BE49-F238E27FC236}">
-                <a16:creationId xmlns:a16="http://schemas.microsoft.com/office/drawing/2014/main" id="{3210E315-A08C-47C2-881C-A1F7D60DCD59}"/>
+                <ns2:creationId id="{3210E315-A08C-47C2-881C-A1F7D60DCD59}"/>
               </a:ext>
             </a:extLst>
           </p:cNvPr>
@@ -4482,16 +4482,17 @@
         </p:nvSpPr>
         <p:spPr>
           <a:xfrm>
-            <a:off x="2990850" y="5105400"/>
-            <a:ext cx="238125" cy="9525"/>
-          </a:xfrm>
-          <a:prstGeom prst="line">
-            <a:avLst/>
-          </a:prstGeom>
-          <a:ln w="19050">
-            <a:solidFill>
-              <a:srgbClr val="FFD426"/>
-            </a:solidFill>
+            <a:off x="3057525" y="5029200"/>
+            <a:ext cx="190500" cy="152400"/>
+          </a:xfrm>
+          <a:prstGeom prst="chevron">
+            <a:avLst/>
+          </a:prstGeom>
+          <a:solidFill>
+            <a:srgbClr val="FFD426"/>
+          </a:solidFill>
+          <a:ln w="0">
+            <a:noFill/>
           </a:ln>
         </p:spPr>
         <p:txBody>
@@ -4510,7 +4511,7 @@
           <p:cNvPr id="51" name="Seller-level signals flow node">
             <a:extLst>
               <a:ext uri="{FF2B5EF4-FFF2-40B4-BE49-F238E27FC236}">
-                <a16:creationId xmlns:a16="http://schemas.microsoft.com/office/drawing/2014/main" id="{F5E6095A-6A9C-49F3-A97B-339B96C4F048}"/>
+                <ns2:creationId id="{F5E6095A-6A9C-49F3-A97B-339B96C4F048}"/>
               </a:ext>
             </a:extLst>
           </p:cNvPr>
@@ -4549,7 +4550,7 @@
           <p:cNvPr id="52" name="Seller-level signals flow title">
             <a:extLst>
               <a:ext uri="{FF2B5EF4-FFF2-40B4-BE49-F238E27FC236}">
-                <a16:creationId xmlns:a16="http://schemas.microsoft.com/office/drawing/2014/main" id="{B64306AD-2C64-4117-940F-62837FE5EF2C}"/>
+                <ns2:creationId id="{B64306AD-2C64-4117-940F-62837FE5EF2C}"/>
               </a:ext>
             </a:extLst>
           </p:cNvPr>
@@ -4593,7 +4594,7 @@
           <p:cNvPr id="53" name="Seller-level signals flow sub">
             <a:extLst>
               <a:ext uri="{FF2B5EF4-FFF2-40B4-BE49-F238E27FC236}">
-                <a16:creationId xmlns:a16="http://schemas.microsoft.com/office/drawing/2014/main" id="{8C30BFA1-5952-479F-B5E3-391E5874D34F}"/>
+                <ns2:creationId id="{8C30BFA1-5952-479F-B5E3-391E5874D34F}"/>
               </a:ext>
             </a:extLst>
           </p:cNvPr>
@@ -4637,7 +4638,7 @@
           <p:cNvPr id="54" name="Scoring flow arrow">
             <a:extLst>
               <a:ext uri="{FF2B5EF4-FFF2-40B4-BE49-F238E27FC236}">
-                <a16:creationId xmlns:a16="http://schemas.microsoft.com/office/drawing/2014/main" id="{197806AB-87A7-448B-9F2C-9E7C1B1153B5}"/>
+                <ns2:creationId id="{197806AB-87A7-448B-9F2C-9E7C1B1153B5}"/>
               </a:ext>
             </a:extLst>
           </p:cNvPr>
@@ -4648,16 +4649,17 @@
         </p:nvSpPr>
         <p:spPr>
           <a:xfrm>
-            <a:off x="5800725" y="5105400"/>
-            <a:ext cx="238125" cy="9525"/>
-          </a:xfrm>
-          <a:prstGeom prst="line">
-            <a:avLst/>
-          </a:prstGeom>
-          <a:ln w="19050">
-            <a:solidFill>
-              <a:srgbClr val="FFD426"/>
-            </a:solidFill>
+            <a:off x="5867400" y="5029200"/>
+            <a:ext cx="190500" cy="152400"/>
+          </a:xfrm>
+          <a:prstGeom prst="chevron">
+            <a:avLst/>
+          </a:prstGeom>
+          <a:solidFill>
+            <a:srgbClr val="FFD426"/>
+          </a:solidFill>
+          <a:ln w="0">
+            <a:noFill/>
           </a:ln>
         </p:spPr>
         <p:txBody>
@@ -4673,7 +4675,7 @@
           <p:cNvPr id="55" name="Weighted score flow node">
             <a:extLst>
               <a:ext uri="{FF2B5EF4-FFF2-40B4-BE49-F238E27FC236}">
-                <a16:creationId xmlns:a16="http://schemas.microsoft.com/office/drawing/2014/main" id="{8521D761-1E4B-439E-BE41-C720C69E78B3}"/>
+                <ns2:creationId id="{8521D761-1E4B-439E-BE41-C720C69E78B3}"/>
               </a:ext>
             </a:extLst>
           </p:cNvPr>
@@ -4712,7 +4714,7 @@
           <p:cNvPr id="56" name="Weighted score flow title">
             <a:extLst>
               <a:ext uri="{FF2B5EF4-FFF2-40B4-BE49-F238E27FC236}">
-                <a16:creationId xmlns:a16="http://schemas.microsoft.com/office/drawing/2014/main" id="{4D8BBBFF-0C25-4B66-8FB2-3D1F31EFAEF6}"/>
+                <ns2:creationId id="{4D8BBBFF-0C25-4B66-8FB2-3D1F31EFAEF6}"/>
               </a:ext>
             </a:extLst>
           </p:cNvPr>
@@ -4756,7 +4758,7 @@
           <p:cNvPr id="57" name="Weighted score flow sub">
             <a:extLst>
               <a:ext uri="{FF2B5EF4-FFF2-40B4-BE49-F238E27FC236}">
-                <a16:creationId xmlns:a16="http://schemas.microsoft.com/office/drawing/2014/main" id="{14CA54AA-B2C8-4629-8C0F-B16CD5CA3561}"/>
+                <ns2:creationId id="{14CA54AA-B2C8-4629-8C0F-B16CD5CA3561}"/>
               </a:ext>
             </a:extLst>
           </p:cNvPr>
@@ -4800,7 +4802,7 @@
           <p:cNvPr id="58" name="Scoring flow arrow">
             <a:extLst>
               <a:ext uri="{FF2B5EF4-FFF2-40B4-BE49-F238E27FC236}">
-                <a16:creationId xmlns:a16="http://schemas.microsoft.com/office/drawing/2014/main" id="{DBB14361-6641-466D-BC24-AD870E154D01}"/>
+                <ns2:creationId id="{DBB14361-6641-466D-BC24-AD870E154D01}"/>
               </a:ext>
             </a:extLst>
           </p:cNvPr>
@@ -4811,16 +4813,17 @@
         </p:nvSpPr>
         <p:spPr>
           <a:xfrm>
-            <a:off x="8610600" y="5105400"/>
-            <a:ext cx="238125" cy="9525"/>
-          </a:xfrm>
-          <a:prstGeom prst="line">
-            <a:avLst/>
-          </a:prstGeom>
-          <a:ln w="19050">
-            <a:solidFill>
-              <a:srgbClr val="FFD426"/>
-            </a:solidFill>
+            <a:off x="8677275" y="5029200"/>
+            <a:ext cx="190500" cy="152400"/>
+          </a:xfrm>
+          <a:prstGeom prst="chevron">
+            <a:avLst/>
+          </a:prstGeom>
+          <a:solidFill>
+            <a:srgbClr val="FFD426"/>
+          </a:solidFill>
+          <a:ln w="0">
+            <a:noFill/>
           </a:ln>
         </p:spPr>
         <p:txBody>
@@ -4836,7 +4839,7 @@
           <p:cNvPr id="59" name="Ranked SMB list flow node">
             <a:extLst>
               <a:ext uri="{FF2B5EF4-FFF2-40B4-BE49-F238E27FC236}">
-                <a16:creationId xmlns:a16="http://schemas.microsoft.com/office/drawing/2014/main" id="{0CAD2441-D62F-43BD-8563-74BEBDAA21D3}"/>
+                <ns2:creationId id="{0CAD2441-D62F-43BD-8563-74BEBDAA21D3}"/>
               </a:ext>
             </a:extLst>
           </p:cNvPr>
@@ -4875,7 +4878,7 @@
           <p:cNvPr id="60" name="Ranked SMB list flow title">
             <a:extLst>
               <a:ext uri="{FF2B5EF4-FFF2-40B4-BE49-F238E27FC236}">
-                <a16:creationId xmlns:a16="http://schemas.microsoft.com/office/drawing/2014/main" id="{5474439C-A5FC-456C-A261-876B2BD3B570}"/>
+                <ns2:creationId id="{5474439C-A5FC-456C-A261-876B2BD3B570}"/>
               </a:ext>
             </a:extLst>
           </p:cNvPr>
@@ -4919,7 +4922,7 @@
           <p:cNvPr id="61" name="Ranked SMB list flow sub">
             <a:extLst>
               <a:ext uri="{FF2B5EF4-FFF2-40B4-BE49-F238E27FC236}">
-                <a16:creationId xmlns:a16="http://schemas.microsoft.com/office/drawing/2014/main" id="{CE7F21BB-EACA-4F03-8B7C-53AC29E6E3F3}"/>
+                <ns2:creationId id="{CE7F21BB-EACA-4F03-8B7C-53AC29E6E3F3}"/>
               </a:ext>
             </a:extLst>
           </p:cNvPr>
@@ -4958,130 +4961,10 @@
           </a:p>
         </p:txBody>
       </p:sp>
-      <p:sp>
-        <p:nvSpPr>
-          <p:cNvPr id="62" name="Scoring flow arrowhead">
-            <a:extLst>
-              <a:ext uri="{FF2B5EF4-FFF2-40B4-BE49-F238E27FC236}">
-                <a16:creationId xmlns:a16="http://schemas.microsoft.com/office/drawing/2014/main" id="{D05CFB6C-8D02-44FC-AD74-91DF3EA6D5FD}"/>
-              </a:ext>
-            </a:extLst>
-          </p:cNvPr>
-          <p:cNvSpPr>
-            <a:spLocks noGrp="1"/>
-          </p:cNvSpPr>
-          <p:nvPr/>
-        </p:nvSpPr>
-        <p:spPr>
-          <a:xfrm rot="5400000">
-            <a:off x="3209925" y="5057775"/>
-            <a:ext cx="104775" cy="114300"/>
-          </a:xfrm>
-          <a:prstGeom prst="triangle">
-            <a:avLst/>
-          </a:prstGeom>
-          <a:solidFill>
-            <a:srgbClr val="FFD426"/>
-          </a:solidFill>
-          <a:ln w="0">
-            <a:solidFill>
-              <a:srgbClr val="FFD426"/>
-            </a:solidFill>
-          </a:ln>
-        </p:spPr>
-        <p:txBody>
-          <a:bodyPr/>
-          <a:lstStyle/>
-          <a:p>
-            <a:pPr marL="0" indent="0" algn="l">
-              <a:buNone/>
-            </a:pPr>
-            <a:endParaRPr/>
-          </a:p>
-        </p:txBody>
-      </p:sp>
-      <p:sp>
-        <p:nvSpPr>
-          <p:cNvPr id="63" name="Scoring flow arrowhead">
-            <a:extLst>
-              <a:ext uri="{FF2B5EF4-FFF2-40B4-BE49-F238E27FC236}">
-                <a16:creationId xmlns:a16="http://schemas.microsoft.com/office/drawing/2014/main" id="{C200B03B-12DA-4C24-9311-151273DF82F6}"/>
-              </a:ext>
-            </a:extLst>
-          </p:cNvPr>
-          <p:cNvSpPr>
-            <a:spLocks noGrp="1"/>
-          </p:cNvSpPr>
-          <p:nvPr/>
-        </p:nvSpPr>
-        <p:spPr>
-          <a:xfrm rot="5400000">
-            <a:off x="6019800" y="5057775"/>
-            <a:ext cx="104775" cy="114300"/>
-          </a:xfrm>
-          <a:prstGeom prst="triangle">
-            <a:avLst/>
-          </a:prstGeom>
-          <a:solidFill>
-            <a:srgbClr val="FFD426"/>
-          </a:solidFill>
-          <a:ln w="0">
-            <a:solidFill>
-              <a:srgbClr val="FFD426"/>
-            </a:solidFill>
-          </a:ln>
-        </p:spPr>
-        <p:txBody>
-          <a:bodyPr/>
-          <a:lstStyle/>
-          <a:p>
-            <a:endParaRPr/>
-          </a:p>
-        </p:txBody>
-      </p:sp>
-      <p:sp>
-        <p:nvSpPr>
-          <p:cNvPr id="64" name="Scoring flow arrowhead">
-            <a:extLst>
-              <a:ext uri="{FF2B5EF4-FFF2-40B4-BE49-F238E27FC236}">
-                <a16:creationId xmlns:a16="http://schemas.microsoft.com/office/drawing/2014/main" id="{283AA54C-582E-4185-A140-A82E61B97525}"/>
-              </a:ext>
-            </a:extLst>
-          </p:cNvPr>
-          <p:cNvSpPr>
-            <a:spLocks noGrp="1"/>
-          </p:cNvSpPr>
-          <p:nvPr/>
-        </p:nvSpPr>
-        <p:spPr>
-          <a:xfrm rot="5400000">
-            <a:off x="8829675" y="5057775"/>
-            <a:ext cx="104775" cy="114300"/>
-          </a:xfrm>
-          <a:prstGeom prst="triangle">
-            <a:avLst/>
-          </a:prstGeom>
-          <a:solidFill>
-            <a:srgbClr val="FFD426"/>
-          </a:solidFill>
-          <a:ln w="0">
-            <a:solidFill>
-              <a:srgbClr val="FFD426"/>
-            </a:solidFill>
-          </a:ln>
-        </p:spPr>
-        <p:txBody>
-          <a:bodyPr/>
-          <a:lstStyle/>
-          <a:p>
-            <a:endParaRPr/>
-          </a:p>
-        </p:txBody>
-      </p:sp>
     </p:spTree>
     <p:extLst>
       <p:ext uri="{BB962C8B-B14F-4D97-AF65-F5344CB8AC3E}">
-        <p14:creationId xmlns:p14="http://schemas.microsoft.com/office/powerpoint/2010/main" val="1565786713"/>
+        <ns3:creationId val="1565786713"/>
       </p:ext>
     </p:extLst>
   </p:cSld>
@@ -9262,45 +9145,45 @@
 </file>
 
 <file path=ppt/slides/slide6.xml><?xml version="1.0" encoding="utf-8"?>
-<p:sld xmlns:a="http://schemas.openxmlformats.org/drawingml/2006/main" xmlns:r="http://schemas.openxmlformats.org/officeDocument/2006/relationships" xmlns:p="http://schemas.openxmlformats.org/presentationml/2006/main">
-  <p:cSld>
-    <p:bg>
-      <p:bgPr>
+<ns0:sld xmlns:a="http://schemas.openxmlformats.org/drawingml/2006/main" xmlns:ns0="http://schemas.openxmlformats.org/presentationml/2006/main" xmlns:ns2="http://schemas.microsoft.com/office/drawing/2014/main" xmlns:ns3="http://schemas.microsoft.com/office/powerpoint/2010/main">
+  <ns0:cSld>
+    <ns0:bg>
+      <ns0:bgPr>
         <a:solidFill>
           <a:srgbClr val="050505"/>
         </a:solidFill>
         <a:effectLst/>
-      </p:bgPr>
-    </p:bg>
-    <p:spTree>
-      <p:nvGrpSpPr>
-        <p:cNvPr id="1" name=""/>
-        <p:cNvGrpSpPr/>
-        <p:nvPr/>
-      </p:nvGrpSpPr>
-      <p:grpSpPr>
+      </ns0:bgPr>
+    </ns0:bg>
+    <ns0:spTree>
+      <ns0:nvGrpSpPr>
+        <ns0:cNvPr id="1" name=""/>
+        <ns0:cNvGrpSpPr/>
+        <ns0:nvPr/>
+      </ns0:nvGrpSpPr>
+      <ns0:grpSpPr>
         <a:xfrm>
           <a:off x="0" y="0"/>
           <a:ext cx="0" cy="0"/>
           <a:chOff x="0" y="0"/>
           <a:chExt cx="0" cy="0"/>
         </a:xfrm>
-      </p:grpSpPr>
-      <p:sp>
-        <p:nvSpPr>
-          <p:cNvPr id="2" name="Text">
-            <a:extLst>
-              <a:ext uri="{FF2B5EF4-FFF2-40B4-BE49-F238E27FC236}">
-                <a16:creationId xmlns:a16="http://schemas.microsoft.com/office/drawing/2014/main" id="{9B99C13B-D96C-4CE3-A99D-EEC47E04FC52}"/>
-              </a:ext>
-            </a:extLst>
-          </p:cNvPr>
-          <p:cNvSpPr>
-            <a:spLocks noGrp="1"/>
-          </p:cNvSpPr>
-          <p:nvPr/>
-        </p:nvSpPr>
-        <p:spPr>
+      </ns0:grpSpPr>
+      <ns0:sp>
+        <ns0:nvSpPr>
+          <ns0:cNvPr id="2" name="Text">
+            <a:extLst>
+              <a:ext uri="{FF2B5EF4-FFF2-40B4-BE49-F238E27FC236}">
+                <ns2:creationId id="{9B99C13B-D96C-4CE3-A99D-EEC47E04FC52}"/>
+              </a:ext>
+            </a:extLst>
+          </ns0:cNvPr>
+          <ns0:cNvSpPr>
+            <a:spLocks noGrp="1"/>
+          </ns0:cNvSpPr>
+          <ns0:nvPr/>
+        </ns0:nvSpPr>
+        <ns0:spPr>
           <a:xfrm>
             <a:off x="361950" y="323850"/>
             <a:ext cx="819150" cy="628650"/>
@@ -9315,8 +9198,8 @@
               </a:srgbClr>
             </a:solidFill>
           </a:ln>
-        </p:spPr>
-        <p:txBody>
+        </ns0:spPr>
+        <ns0:txBody>
           <a:bodyPr lIns="57150" tIns="38100" rIns="57150" bIns="38100" anchor="t"/>
           <a:lstStyle/>
           <a:p>
@@ -9343,23 +9226,23 @@
               <a:t>01</a:t>
             </a:r>
           </a:p>
-        </p:txBody>
-      </p:sp>
-      <p:sp>
-        <p:nvSpPr>
-          <p:cNvPr id="3" name="Text">
-            <a:extLst>
-              <a:ext uri="{FF2B5EF4-FFF2-40B4-BE49-F238E27FC236}">
-                <a16:creationId xmlns:a16="http://schemas.microsoft.com/office/drawing/2014/main" id="{F418B9B4-1E2F-4CC1-B49D-5F6E73EACFA5}"/>
-              </a:ext>
-            </a:extLst>
-          </p:cNvPr>
-          <p:cNvSpPr>
-            <a:spLocks noGrp="1"/>
-          </p:cNvSpPr>
-          <p:nvPr/>
-        </p:nvSpPr>
-        <p:spPr>
+        </ns0:txBody>
+      </ns0:sp>
+      <ns0:sp>
+        <ns0:nvSpPr>
+          <ns0:cNvPr id="3" name="Text">
+            <a:extLst>
+              <a:ext uri="{FF2B5EF4-FFF2-40B4-BE49-F238E27FC236}">
+                <ns2:creationId id="{F418B9B4-1E2F-4CC1-B49D-5F6E73EACFA5}"/>
+              </a:ext>
+            </a:extLst>
+          </ns0:cNvPr>
+          <ns0:cNvSpPr>
+            <a:spLocks noGrp="1"/>
+          </ns0:cNvSpPr>
+          <ns0:nvPr/>
+        </ns0:nvSpPr>
+        <ns0:spPr>
           <a:xfrm>
             <a:off x="1257300" y="323850"/>
             <a:ext cx="9953625" cy="714375"/>
@@ -9374,8 +9257,8 @@
               </a:srgbClr>
             </a:solidFill>
           </a:ln>
-        </p:spPr>
-        <p:txBody>
+        </ns0:spPr>
+        <ns0:txBody>
           <a:bodyPr lIns="57150" tIns="38100" rIns="57150" bIns="38100" anchor="t"/>
           <a:lstStyle/>
           <a:p>
@@ -9402,23 +9285,23 @@
               <a:t>1.4 Category Specialization</a:t>
             </a:r>
           </a:p>
-        </p:txBody>
-      </p:sp>
-      <p:sp>
-        <p:nvSpPr>
-          <p:cNvPr id="5" name="Divider">
-            <a:extLst>
-              <a:ext uri="{FF2B5EF4-FFF2-40B4-BE49-F238E27FC236}">
-                <a16:creationId xmlns:a16="http://schemas.microsoft.com/office/drawing/2014/main" id="{389B6C05-0CB8-47D9-807C-9FB880C49BFF}"/>
-              </a:ext>
-            </a:extLst>
-          </p:cNvPr>
-          <p:cNvSpPr>
-            <a:spLocks noGrp="1"/>
-          </p:cNvSpPr>
-          <p:nvPr/>
-        </p:nvSpPr>
-        <p:spPr>
+        </ns0:txBody>
+      </ns0:sp>
+      <ns0:sp>
+        <ns0:nvSpPr>
+          <ns0:cNvPr id="5" name="Divider">
+            <a:extLst>
+              <a:ext uri="{FF2B5EF4-FFF2-40B4-BE49-F238E27FC236}">
+                <ns2:creationId id="{389B6C05-0CB8-47D9-807C-9FB880C49BFF}"/>
+              </a:ext>
+            </a:extLst>
+          </ns0:cNvPr>
+          <ns0:cNvSpPr>
+            <a:spLocks noGrp="1"/>
+          </ns0:cNvSpPr>
+          <ns0:nvPr/>
+        </ns0:nvSpPr>
+        <ns0:spPr>
           <a:xfrm>
             <a:off x="457200" y="1160000"/>
             <a:ext cx="11277600" cy="0"/>
@@ -9431,30 +9314,30 @@
               <a:srgbClr val="3A3A3A"/>
             </a:solidFill>
           </a:ln>
-        </p:spPr>
-        <p:txBody>
+        </ns0:spPr>
+        <ns0:txBody>
           <a:bodyPr/>
           <a:lstStyle/>
           <a:p>
             <a:endParaRPr/>
           </a:p>
-        </p:txBody>
-      </p:sp>
-      <p:sp>
-        <p:nvSpPr>
-          <p:cNvPr id="13" name="Divider">
-            <a:extLst>
-              <a:ext uri="{FF2B5EF4-FFF2-40B4-BE49-F238E27FC236}">
-                <a16:creationId xmlns:a16="http://schemas.microsoft.com/office/drawing/2014/main" id="{DAE51419-1FE7-4CE0-922B-B1D781F0F39A}"/>
-              </a:ext>
-            </a:extLst>
-          </p:cNvPr>
-          <p:cNvSpPr>
-            <a:spLocks noGrp="1"/>
-          </p:cNvSpPr>
-          <p:nvPr/>
-        </p:nvSpPr>
-        <p:spPr>
+        </ns0:txBody>
+      </ns0:sp>
+      <ns0:sp>
+        <ns0:nvSpPr>
+          <ns0:cNvPr id="13" name="Divider">
+            <a:extLst>
+              <a:ext uri="{FF2B5EF4-FFF2-40B4-BE49-F238E27FC236}">
+                <ns2:creationId id="{DAE51419-1FE7-4CE0-922B-B1D781F0F39A}"/>
+              </a:ext>
+            </a:extLst>
+          </ns0:cNvPr>
+          <ns0:cNvSpPr>
+            <a:spLocks noGrp="1"/>
+          </ns0:cNvSpPr>
+          <ns0:nvPr/>
+        </ns0:nvSpPr>
+        <ns0:spPr>
           <a:xfrm>
             <a:off x="457200" y="6210300"/>
             <a:ext cx="11277600" cy="0"/>
@@ -9467,30 +9350,30 @@
               <a:srgbClr val="3A3A3A"/>
             </a:solidFill>
           </a:ln>
-        </p:spPr>
-        <p:txBody>
+        </ns0:spPr>
+        <ns0:txBody>
           <a:bodyPr/>
           <a:lstStyle/>
           <a:p>
             <a:endParaRPr/>
           </a:p>
-        </p:txBody>
-      </p:sp>
-      <p:sp>
-        <p:nvSpPr>
-          <p:cNvPr id="14" name="Text">
-            <a:extLst>
-              <a:ext uri="{FF2B5EF4-FFF2-40B4-BE49-F238E27FC236}">
-                <a16:creationId xmlns:a16="http://schemas.microsoft.com/office/drawing/2014/main" id="{156E590D-3E7B-43ED-86D8-86950CA69CF0}"/>
-              </a:ext>
-            </a:extLst>
-          </p:cNvPr>
-          <p:cNvSpPr>
-            <a:spLocks noGrp="1"/>
-          </p:cNvSpPr>
-          <p:nvPr/>
-        </p:nvSpPr>
-        <p:spPr>
+        </ns0:txBody>
+      </ns0:sp>
+      <ns0:sp>
+        <ns0:nvSpPr>
+          <ns0:cNvPr id="14" name="Text">
+            <a:extLst>
+              <a:ext uri="{FF2B5EF4-FFF2-40B4-BE49-F238E27FC236}">
+                <ns2:creationId id="{156E590D-3E7B-43ED-86D8-86950CA69CF0}"/>
+              </a:ext>
+            </a:extLst>
+          </ns0:cNvPr>
+          <ns0:cNvSpPr>
+            <a:spLocks noGrp="1"/>
+          </ns0:cNvSpPr>
+          <ns0:nvPr/>
+        </ns0:nvSpPr>
+        <ns0:spPr>
           <a:xfrm>
             <a:off x="457200" y="6286500"/>
             <a:ext cx="7239000" cy="228600"/>
@@ -9505,8 +9388,8 @@
               </a:srgbClr>
             </a:solidFill>
           </a:ln>
-        </p:spPr>
-        <p:txBody>
+        </ns0:spPr>
+        <ns0:txBody>
           <a:bodyPr lIns="57150" tIns="38100" rIns="57150" bIns="38100" anchor="t"/>
           <a:lstStyle/>
           <a:p>
@@ -9533,23 +9416,23 @@
               <a:t>SMB Identification</a:t>
             </a:r>
           </a:p>
-        </p:txBody>
-      </p:sp>
-      <p:sp>
-        <p:nvSpPr>
-          <p:cNvPr id="15" name="Text">
-            <a:extLst>
-              <a:ext uri="{FF2B5EF4-FFF2-40B4-BE49-F238E27FC236}">
-                <a16:creationId xmlns:a16="http://schemas.microsoft.com/office/drawing/2014/main" id="{D948341B-6D56-43D2-9783-B62A329B3143}"/>
-              </a:ext>
-            </a:extLst>
-          </p:cNvPr>
-          <p:cNvSpPr>
-            <a:spLocks noGrp="1"/>
-          </p:cNvSpPr>
-          <p:nvPr/>
-        </p:nvSpPr>
-        <p:spPr>
+        </ns0:txBody>
+      </ns0:sp>
+      <ns0:sp>
+        <ns0:nvSpPr>
+          <ns0:cNvPr id="15" name="Text">
+            <a:extLst>
+              <a:ext uri="{FF2B5EF4-FFF2-40B4-BE49-F238E27FC236}">
+                <ns2:creationId id="{D948341B-6D56-43D2-9783-B62A329B3143}"/>
+              </a:ext>
+            </a:extLst>
+          </ns0:cNvPr>
+          <ns0:cNvSpPr>
+            <a:spLocks noGrp="1"/>
+          </ns0:cNvSpPr>
+          <ns0:nvPr/>
+        </ns0:nvSpPr>
+        <ns0:spPr>
           <a:xfrm>
             <a:off x="11144250" y="6286500"/>
             <a:ext cx="590550" cy="228600"/>
@@ -9564,8 +9447,8 @@
               </a:srgbClr>
             </a:solidFill>
           </a:ln>
-        </p:spPr>
-        <p:txBody>
+        </ns0:spPr>
+        <ns0:txBody>
           <a:bodyPr lIns="57150" tIns="38100" rIns="57150" bIns="38100" anchor="t"/>
           <a:lstStyle/>
           <a:p>
@@ -9592,23 +9475,23 @@
               <a:t>05 / 07</a:t>
             </a:r>
           </a:p>
-        </p:txBody>
-      </p:sp>
-      <p:sp>
-        <p:nvSpPr>
-          <p:cNvPr id="16" name="Combined signal">
-            <a:extLst>
-              <a:ext uri="{FF2B5EF4-FFF2-40B4-BE49-F238E27FC236}">
-                <a16:creationId xmlns:a16="http://schemas.microsoft.com/office/drawing/2014/main" id="{D83D076D-E780-418E-AF42-7556841364D6}"/>
-              </a:ext>
-            </a:extLst>
-          </p:cNvPr>
-          <p:cNvSpPr>
-            <a:spLocks noGrp="1"/>
-          </p:cNvSpPr>
-          <p:nvPr/>
-        </p:nvSpPr>
-        <p:spPr>
+        </ns0:txBody>
+      </ns0:sp>
+      <ns0:sp>
+        <ns0:nvSpPr>
+          <ns0:cNvPr id="16" name="Combined signal">
+            <a:extLst>
+              <a:ext uri="{FF2B5EF4-FFF2-40B4-BE49-F238E27FC236}">
+                <ns2:creationId id="{D83D076D-E780-418E-AF42-7556841364D6}"/>
+              </a:ext>
+            </a:extLst>
+          </ns0:cNvPr>
+          <ns0:cNvSpPr>
+            <a:spLocks noGrp="1"/>
+          </ns0:cNvSpPr>
+          <ns0:nvPr/>
+        </ns0:nvSpPr>
+        <ns0:spPr>
           <a:xfrm>
             <a:off x="609600" y="1428750"/>
             <a:ext cx="8572500" cy="228600"/>
@@ -9620,8 +9503,8 @@
           <a:ln w="0">
             <a:noFill/>
           </a:ln>
-        </p:spPr>
-        <p:txBody>
+        </ns0:spPr>
+        <ns0:txBody>
           <a:bodyPr wrap="square" lIns="0" tIns="0" rIns="0" bIns="0" anchor="t"/>
           <a:lstStyle/>
           <a:p>
@@ -9637,26 +9520,26 @@
                 <a:ea typeface="Arial"/>
                 <a:cs typeface="Arial"/>
               </a:rPr>
-              <a:t>Signal: SMBs often specialize in one category or a coherent category cluster.</a:t>
+              <a:t>Signal: SMBs often show repeated supply within the same category or subcategory.</a:t>
             </a:r>
           </a:p>
-        </p:txBody>
-      </p:sp>
-      <p:sp>
-        <p:nvSpPr>
-          <p:cNvPr id="17" name="Potential Metrics">
-            <a:extLst>
-              <a:ext uri="{FF2B5EF4-FFF2-40B4-BE49-F238E27FC236}">
-                <a16:creationId xmlns:a16="http://schemas.microsoft.com/office/drawing/2014/main" id="{803860D4-8BEE-4C49-A0F7-6B5EC0893A07}"/>
-              </a:ext>
-            </a:extLst>
-          </p:cNvPr>
-          <p:cNvSpPr>
-            <a:spLocks noGrp="1"/>
-          </p:cNvSpPr>
-          <p:nvPr/>
-        </p:nvSpPr>
-        <p:spPr>
+        </ns0:txBody>
+      </ns0:sp>
+      <ns0:sp>
+        <ns0:nvSpPr>
+          <ns0:cNvPr id="17" name="Potential Metrics">
+            <a:extLst>
+              <a:ext uri="{FF2B5EF4-FFF2-40B4-BE49-F238E27FC236}">
+                <ns2:creationId id="{803860D4-8BEE-4C49-A0F7-6B5EC0893A07}"/>
+              </a:ext>
+            </a:extLst>
+          </ns0:cNvPr>
+          <ns0:cNvSpPr>
+            <a:spLocks noGrp="1"/>
+          </ns0:cNvSpPr>
+          <ns0:nvPr/>
+        </ns0:nvSpPr>
+        <ns0:spPr>
           <a:xfrm>
             <a:off x="609600" y="1809750"/>
             <a:ext cx="2381250" cy="228600"/>
@@ -9668,8 +9551,8 @@
           <a:ln w="0">
             <a:noFill/>
           </a:ln>
-        </p:spPr>
-        <p:txBody>
+        </ns0:spPr>
+        <ns0:txBody>
           <a:bodyPr wrap="square" lIns="0" tIns="0" rIns="0" bIns="0" anchor="t"/>
           <a:lstStyle/>
           <a:p>
@@ -9688,23 +9571,23 @@
               <a:t>Potential Metrics</a:t>
             </a:r>
           </a:p>
-        </p:txBody>
-      </p:sp>
-      <p:sp>
-        <p:nvSpPr>
-          <p:cNvPr id="18" name="Scoring window">
-            <a:extLst>
-              <a:ext uri="{FF2B5EF4-FFF2-40B4-BE49-F238E27FC236}">
-                <a16:creationId xmlns:a16="http://schemas.microsoft.com/office/drawing/2014/main" id="{71E17E3F-18A3-4169-9218-018DB913F7F4}"/>
-              </a:ext>
-            </a:extLst>
-          </p:cNvPr>
-          <p:cNvSpPr>
-            <a:spLocks noGrp="1"/>
-          </p:cNvSpPr>
-          <p:nvPr/>
-        </p:nvSpPr>
-        <p:spPr>
+        </ns0:txBody>
+      </ns0:sp>
+      <ns0:sp>
+        <ns0:nvSpPr>
+          <ns0:cNvPr id="18" name="Scoring window">
+            <a:extLst>
+              <a:ext uri="{FF2B5EF4-FFF2-40B4-BE49-F238E27FC236}">
+                <ns2:creationId id="{71E17E3F-18A3-4169-9218-018DB913F7F4}"/>
+              </a:ext>
+            </a:extLst>
+          </ns0:cNvPr>
+          <ns0:cNvSpPr>
+            <a:spLocks noGrp="1"/>
+          </ns0:cNvSpPr>
+          <ns0:nvPr/>
+        </ns0:nvSpPr>
+        <ns0:spPr>
           <a:xfrm>
             <a:off x="609600" y="2038350"/>
             <a:ext cx="6858000" cy="171450"/>
@@ -9716,8 +9599,8 @@
           <a:ln w="0">
             <a:noFill/>
           </a:ln>
-        </p:spPr>
-        <p:txBody>
+        </ns0:spPr>
+        <ns0:txBody>
           <a:bodyPr wrap="square" lIns="0" tIns="0" rIns="0" bIns="0" anchor="t"/>
           <a:lstStyle/>
           <a:p>
@@ -9736,24 +9619,24 @@
               <a:t>Scoring window: last 12 months; use main category and specific subcategory.</a:t>
             </a:r>
           </a:p>
-        </p:txBody>
-      </p:sp>
-      <p:graphicFrame>
-        <p:nvGraphicFramePr>
-          <p:cNvPr id="19" name="Potential Metrics table"/>
-          <p:cNvGraphicFramePr/>
-          <p:nvPr>
-            <p:extLst>
-              <p:ext uri="{D42A27DB-BD31-4B8C-83A1-F6EECF244321}">
-                <p14:modId xmlns:p14="http://schemas.microsoft.com/office/powerpoint/2010/main" val="2713399914"/>
-              </p:ext>
-            </p:extLst>
-          </p:nvPr>
-        </p:nvGraphicFramePr>
-        <p:xfrm>
+        </ns0:txBody>
+      </ns0:sp>
+      <ns0:graphicFrame>
+        <ns0:nvGraphicFramePr>
+          <ns0:cNvPr id="19" name="Potential Metrics table"/>
+          <ns0:cNvGraphicFramePr/>
+          <ns0:nvPr>
+            <ns0:extLst>
+              <ns0:ext uri="{D42A27DB-BD31-4B8C-83A1-F6EECF244321}">
+                <ns3:modId val="2713399914"/>
+              </ns0:ext>
+            </ns0:extLst>
+          </ns0:nvPr>
+        </ns0:nvGraphicFramePr>
+        <ns0:xfrm>
           <a:off x="609600" y="2399549"/>
-          <a:ext cx="10972800" cy="1120140"/>
-        </p:xfrm>
+          <a:ext cx="10972800" cy="762000"/>
+        </ns0:xfrm>
         <a:graphic>
           <a:graphicData uri="http://schemas.openxmlformats.org/drawingml/2006/table">
             <a:tbl>
@@ -9764,21 +9647,21 @@
                 <a:gridCol w="2952750">
                   <a:extLst>
                     <a:ext uri="{9D8B030D-6E8A-4147-A177-3AD203B41FA5}">
-                      <a16:colId xmlns:a16="http://schemas.microsoft.com/office/drawing/2014/main" val="20000"/>
+                      <ns2:colId val="20000"/>
                     </a:ext>
                   </a:extLst>
                 </a:gridCol>
                 <a:gridCol w="3238500">
                   <a:extLst>
                     <a:ext uri="{9D8B030D-6E8A-4147-A177-3AD203B41FA5}">
-                      <a16:colId xmlns:a16="http://schemas.microsoft.com/office/drawing/2014/main" val="20001"/>
+                      <ns2:colId val="20001"/>
                     </a:ext>
                   </a:extLst>
                 </a:gridCol>
                 <a:gridCol w="4781550">
                   <a:extLst>
                     <a:ext uri="{9D8B030D-6E8A-4147-A177-3AD203B41FA5}">
-                      <a16:colId xmlns:a16="http://schemas.microsoft.com/office/drawing/2014/main" val="20002"/>
+                      <ns2:colId val="20002"/>
                     </a:ext>
                   </a:extLst>
                 </a:gridCol>
@@ -9927,11 +9810,11 @@
                 </a:tc>
                 <a:extLst>
                   <a:ext uri="{0D108BD9-81ED-4DB2-BD59-A6C34878D82A}">
-                    <a16:rowId xmlns:a16="http://schemas.microsoft.com/office/drawing/2014/main" val="10000"/>
+                    <ns2:rowId val="10000"/>
                   </a:ext>
                 </a:extLst>
               </a:tr>
-              <a:tr h="400050">
+              <a:tr h="495300">
                 <a:tc>
                   <a:txBody>
                     <a:bodyPr/>
@@ -9949,7 +9832,7 @@
                           <a:ea typeface="Arial"/>
                           <a:cs typeface="Arial"/>
                         </a:rPr>
-                        <a:t>Repeated listings in same category/subcategory</a:t>
+                        <a:t>Category-adjusted repeated listings</a:t>
                       </a:r>
                     </a:p>
                   </a:txBody>
@@ -9988,15 +9871,15 @@
                         <a:buNone/>
                       </a:pPr>
                       <a:r>
-                        <a:rPr sz="1100" b="1">
+                        <a:rPr sz="1100" b="0">
                           <a:solidFill>
                             <a:srgbClr val="FFD426"/>
                           </a:solidFill>
-                          <a:latin typeface="Arial"/>
-                          <a:ea typeface="Arial"/>
-                          <a:cs typeface="Arial"/>
+                          <a:latin typeface="Menlo"/>
+                          <a:ea typeface="Menlo"/>
+                          <a:cs typeface="Menlo"/>
                         </a:rPr>
-                        <a:t>User id, Ad category</a:t>
+                        <a:t>Ad category</a:t>
                       </a:r>
                     </a:p>
                   </a:txBody>
@@ -10043,7 +9926,7 @@
                           <a:ea typeface="Arial"/>
                           <a:cs typeface="Arial"/>
                         </a:rPr>
-                        <a:t>Captures specialized and sustained supply.</a:t>
+                        <a:t>Repeated listings are more meaningful in some categories than others.</a:t>
                       </a:r>
                     </a:p>
                   </a:txBody>
@@ -10075,177 +9958,29 @@
                 </a:tc>
                 <a:extLst>
                   <a:ext uri="{0D108BD9-81ED-4DB2-BD59-A6C34878D82A}">
-                    <a16:rowId xmlns:a16="http://schemas.microsoft.com/office/drawing/2014/main" val="10001"/>
-                  </a:ext>
-                </a:extLst>
-              </a:tr>
-              <a:tr h="400050">
-                <a:tc>
-                  <a:txBody>
-                    <a:bodyPr/>
-                    <a:lstStyle/>
-                    <a:p>
-                      <a:pPr marL="0" indent="0">
-                        <a:buNone/>
-                      </a:pPr>
-                      <a:r>
-                        <a:rPr sz="1100">
-                          <a:solidFill>
-                            <a:srgbClr val="F3F4F6"/>
-                          </a:solidFill>
-                          <a:latin typeface="Arial"/>
-                          <a:ea typeface="Arial"/>
-                          <a:cs typeface="Arial"/>
-                        </a:rPr>
-                        <a:t>Business-prone categories</a:t>
-                      </a:r>
-                    </a:p>
-                  </a:txBody>
-                  <a:tcPr>
-                    <a:lnL w="6350">
-                      <a:solidFill>
-                        <a:srgbClr val="3A3A3A"/>
-                      </a:solidFill>
-                    </a:lnL>
-                    <a:lnR w="6350">
-                      <a:solidFill>
-                        <a:srgbClr val="3A3A3A"/>
-                      </a:solidFill>
-                    </a:lnR>
-                    <a:lnT w="6350">
-                      <a:solidFill>
-                        <a:srgbClr val="3A3A3A"/>
-                      </a:solidFill>
-                    </a:lnT>
-                    <a:lnB w="6350">
-                      <a:solidFill>
-                        <a:srgbClr val="3A3A3A"/>
-                      </a:solidFill>
-                    </a:lnB>
-                    <a:solidFill>
-                      <a:srgbClr val="050505"/>
-                    </a:solidFill>
-                  </a:tcPr>
-                </a:tc>
-                <a:tc>
-                  <a:txBody>
-                    <a:bodyPr/>
-                    <a:lstStyle/>
-                    <a:p>
-                      <a:pPr marL="0" indent="0">
-                        <a:buNone/>
-                      </a:pPr>
-                      <a:r>
-                        <a:rPr sz="1100" b="1">
-                          <a:solidFill>
-                            <a:srgbClr val="FFD426"/>
-                          </a:solidFill>
-                          <a:latin typeface="Arial"/>
-                          <a:ea typeface="Arial"/>
-                          <a:cs typeface="Arial"/>
-                        </a:rPr>
-                        <a:t>Ad category, Category name</a:t>
-                      </a:r>
-                    </a:p>
-                  </a:txBody>
-                  <a:tcPr>
-                    <a:lnL w="6350">
-                      <a:solidFill>
-                        <a:srgbClr val="3A3A3A"/>
-                      </a:solidFill>
-                    </a:lnL>
-                    <a:lnR w="6350">
-                      <a:solidFill>
-                        <a:srgbClr val="3A3A3A"/>
-                      </a:solidFill>
-                    </a:lnR>
-                    <a:lnT w="6350">
-                      <a:solidFill>
-                        <a:srgbClr val="3A3A3A"/>
-                      </a:solidFill>
-                    </a:lnT>
-                    <a:lnB w="6350">
-                      <a:solidFill>
-                        <a:srgbClr val="3A3A3A"/>
-                      </a:solidFill>
-                    </a:lnB>
-                    <a:solidFill>
-                      <a:srgbClr val="050505"/>
-                    </a:solidFill>
-                  </a:tcPr>
-                </a:tc>
-                <a:tc>
-                  <a:txBody>
-                    <a:bodyPr/>
-                    <a:lstStyle/>
-                    <a:p>
-                      <a:pPr marL="0" indent="0">
-                        <a:buNone/>
-                      </a:pPr>
-                      <a:r>
-                        <a:rPr sz="1100" dirty="0">
-                          <a:solidFill>
-                            <a:srgbClr val="F3F4F6"/>
-                          </a:solidFill>
-                          <a:latin typeface="Arial"/>
-                          <a:ea typeface="Arial"/>
-                          <a:cs typeface="Arial"/>
-                        </a:rPr>
-                        <a:t>Some categories have higher expected SMB share and should raise/lower the score.</a:t>
-                      </a:r>
-                    </a:p>
-                  </a:txBody>
-                  <a:tcPr>
-                    <a:lnL w="6350">
-                      <a:solidFill>
-                        <a:srgbClr val="3A3A3A"/>
-                      </a:solidFill>
-                    </a:lnL>
-                    <a:lnR w="6350">
-                      <a:solidFill>
-                        <a:srgbClr val="3A3A3A"/>
-                      </a:solidFill>
-                    </a:lnR>
-                    <a:lnT w="6350">
-                      <a:solidFill>
-                        <a:srgbClr val="3A3A3A"/>
-                      </a:solidFill>
-                    </a:lnT>
-                    <a:lnB w="6350">
-                      <a:solidFill>
-                        <a:srgbClr val="3A3A3A"/>
-                      </a:solidFill>
-                    </a:lnB>
-                    <a:solidFill>
-                      <a:srgbClr val="050505"/>
-                    </a:solidFill>
-                  </a:tcPr>
-                </a:tc>
-                <a:extLst>
-                  <a:ext uri="{0D108BD9-81ED-4DB2-BD59-A6C34878D82A}">
-                    <a16:rowId xmlns:a16="http://schemas.microsoft.com/office/drawing/2014/main" val="10002"/>
+                    <ns2:rowId val="10001"/>
                   </a:ext>
                 </a:extLst>
               </a:tr>
             </a:tbl>
           </a:graphicData>
         </a:graphic>
-      </p:graphicFrame>
-      <p:sp>
-        <p:nvSpPr>
-          <p:cNvPr id="34" name="Business-prone examples label">
-            <a:extLst>
-              <a:ext uri="{FF2B5EF4-FFF2-40B4-BE49-F238E27FC236}">
-                <a16:creationId xmlns:a16="http://schemas.microsoft.com/office/drawing/2014/main" id="{659BC4DA-48DD-4F7A-AAA1-C8016FE1E228}"/>
-              </a:ext>
-            </a:extLst>
-          </p:cNvPr>
-          <p:cNvSpPr>
-            <a:spLocks noGrp="1"/>
-          </p:cNvSpPr>
-          <p:nvPr/>
-        </p:nvSpPr>
-        <p:spPr>
+      </ns0:graphicFrame>
+      <ns0:sp>
+        <ns0:nvSpPr>
+          <ns0:cNvPr id="34" name="Business-prone examples label">
+            <a:extLst>
+              <a:ext uri="{FF2B5EF4-FFF2-40B4-BE49-F238E27FC236}">
+                <ns2:creationId id="{659BC4DA-48DD-4F7A-AAA1-C8016FE1E228}"/>
+              </a:ext>
+            </a:extLst>
+          </ns0:cNvPr>
+          <ns0:cNvSpPr>
+            <a:spLocks noGrp="1"/>
+          </ns0:cNvSpPr>
+          <ns0:nvPr/>
+        </ns0:nvSpPr>
+        <ns0:spPr>
           <a:xfrm>
             <a:off x="609600" y="3756958"/>
             <a:ext cx="4000500" cy="228600"/>
@@ -10257,8 +9992,8 @@
           <a:ln w="0">
             <a:noFill/>
           </a:ln>
-        </p:spPr>
-        <p:txBody>
+        </ns0:spPr>
+        <ns0:txBody>
           <a:bodyPr wrap="square" lIns="0" tIns="0" rIns="0" bIns="0" anchor="t"/>
           <a:lstStyle/>
           <a:p>
@@ -10274,29 +10009,29 @@
                 <a:ea typeface="Arial"/>
                 <a:cs typeface="Arial"/>
               </a:rPr>
-              <a:t>Business-Prone Category Examples</a:t>
+              <a:t>Threshold Examples</a:t>
             </a:r>
           </a:p>
-        </p:txBody>
-      </p:sp>
-      <p:sp>
-        <p:nvSpPr>
-          <p:cNvPr id="35" name="Example item divider">
-            <a:extLst>
-              <a:ext uri="{FF2B5EF4-FFF2-40B4-BE49-F238E27FC236}">
-                <a16:creationId xmlns:a16="http://schemas.microsoft.com/office/drawing/2014/main" id="{0746B772-4448-42AF-815E-C2D7BD502F99}"/>
-              </a:ext>
-            </a:extLst>
-          </p:cNvPr>
-          <p:cNvSpPr>
-            <a:spLocks noGrp="1"/>
-          </p:cNvSpPr>
-          <p:nvPr/>
-        </p:nvSpPr>
-        <p:spPr>
+        </ns0:txBody>
+      </ns0:sp>
+      <ns0:sp>
+        <ns0:nvSpPr>
+          <ns0:cNvPr id="35" name="Example item divider">
+            <a:extLst>
+              <a:ext uri="{FF2B5EF4-FFF2-40B4-BE49-F238E27FC236}">
+                <ns2:creationId id="{0746B772-4448-42AF-815E-C2D7BD502F99}"/>
+              </a:ext>
+            </a:extLst>
+          </ns0:cNvPr>
+          <ns0:cNvSpPr>
+            <a:spLocks noGrp="1"/>
+          </ns0:cNvSpPr>
+          <ns0:nvPr/>
+        </ns0:nvSpPr>
+        <ns0:spPr>
           <a:xfrm>
             <a:off x="609600" y="3995083"/>
-            <a:ext cx="3333750" cy="9525"/>
+            <a:ext cx="5295900" cy="9525"/>
           </a:xfrm>
           <a:prstGeom prst="line">
             <a:avLst/>
@@ -10306,34 +10041,34 @@
               <a:srgbClr val="1C1C1C"/>
             </a:solidFill>
           </a:ln>
-        </p:spPr>
-        <p:txBody>
+        </ns0:spPr>
+        <ns0:txBody>
           <a:bodyPr/>
           <a:lstStyle/>
           <a:p>
             <a:pPr marL="0" indent="0" algn="l" defTabSz="914400" rtl="0"/>
             <a:endParaRPr/>
           </a:p>
-        </p:txBody>
-      </p:sp>
-      <p:sp>
-        <p:nvSpPr>
-          <p:cNvPr id="36" name="Example categories">
-            <a:extLst>
-              <a:ext uri="{FF2B5EF4-FFF2-40B4-BE49-F238E27FC236}">
-                <a16:creationId xmlns:a16="http://schemas.microsoft.com/office/drawing/2014/main" id="{9B73CDFC-1992-4118-968A-20482CD149D3}"/>
-              </a:ext>
-            </a:extLst>
-          </p:cNvPr>
-          <p:cNvSpPr>
-            <a:spLocks noGrp="1"/>
-          </p:cNvSpPr>
-          <p:nvPr/>
-        </p:nvSpPr>
-        <p:spPr>
+        </ns0:txBody>
+      </ns0:sp>
+      <ns0:sp>
+        <ns0:nvSpPr>
+          <ns0:cNvPr id="36" name="Example categories">
+            <a:extLst>
+              <a:ext uri="{FF2B5EF4-FFF2-40B4-BE49-F238E27FC236}">
+                <ns2:creationId id="{9B73CDFC-1992-4118-968A-20482CD149D3}"/>
+              </a:ext>
+            </a:extLst>
+          </ns0:cNvPr>
+          <ns0:cNvSpPr>
+            <a:spLocks noGrp="1"/>
+          </ns0:cNvSpPr>
+          <ns0:nvPr/>
+        </ns0:nvSpPr>
+        <ns0:spPr>
           <a:xfrm>
             <a:off x="609600" y="4080808"/>
-            <a:ext cx="3333750" cy="400050"/>
+            <a:ext cx="5295900" cy="400050"/>
           </a:xfrm>
           <a:prstGeom prst="rect">
             <a:avLst/>
@@ -10342,8 +10077,8 @@
           <a:ln w="0">
             <a:noFill/>
           </a:ln>
-        </p:spPr>
-        <p:txBody>
+        </ns0:spPr>
+        <ns0:txBody>
           <a:bodyPr wrap="square" lIns="0" tIns="0" rIns="0" bIns="0" anchor="t"/>
           <a:lstStyle/>
           <a:p>
@@ -10351,37 +10086,48 @@
               <a:buNone/>
             </a:pPr>
             <a:r>
-              <a:rPr sz="1000">
-                <a:solidFill>
-                  <a:srgbClr val="A5A5A5"/>
+              <a:rPr sz="1000" b="1">
+                <a:solidFill>
+                  <a:srgbClr val="F3F4F6"/>
                 </a:solidFill>
                 <a:latin typeface="Arial"/>
                 <a:ea typeface="Arial"/>
                 <a:cs typeface="Arial"/>
               </a:rPr>
-              <a:t>Business Goods; Services and Tradespeople</a:t>
+              <a:t>High-value / dealer-like</a:t>
             </a:r>
-          </a:p>
-        </p:txBody>
-      </p:sp>
-      <p:sp>
-        <p:nvSpPr>
-          <p:cNvPr id="37" name="Example why">
-            <a:extLst>
-              <a:ext uri="{FF2B5EF4-FFF2-40B4-BE49-F238E27FC236}">
-                <a16:creationId xmlns:a16="http://schemas.microsoft.com/office/drawing/2014/main" id="{1E0A8FA6-A458-42C1-80BA-A4B07BDF1EF7}"/>
-              </a:ext>
-            </a:extLst>
-          </p:cNvPr>
-          <p:cNvSpPr>
-            <a:spLocks noGrp="1"/>
-          </p:cNvSpPr>
-          <p:nvPr/>
-        </p:nvSpPr>
-        <p:spPr>
+            <a:r>
+              <a:rPr sz="1000" b="0">
+                <a:solidFill>
+                  <a:srgbClr val="A7A7A7"/>
+                </a:solidFill>
+                <a:latin typeface="Arial"/>
+                <a:ea typeface="Arial"/>
+                <a:cs typeface="Arial"/>
+              </a:rPr>
+              <a:t>: Cars; Motorcycles; Caravans and Camping; Water Sports and Boats; Car Parts</a:t>
+            </a:r>
+          </a:p>
+        </ns0:txBody>
+      </ns0:sp>
+      <ns0:sp>
+        <ns0:nvSpPr>
+          <ns0:cNvPr id="37" name="Example why">
+            <a:extLst>
+              <a:ext uri="{FF2B5EF4-FFF2-40B4-BE49-F238E27FC236}">
+                <ns2:creationId id="{1E0A8FA6-A458-42C1-80BA-A4B07BDF1EF7}"/>
+              </a:ext>
+            </a:extLst>
+          </ns0:cNvPr>
+          <ns0:cNvSpPr>
+            <a:spLocks noGrp="1"/>
+          </ns0:cNvSpPr>
+          <ns0:nvPr/>
+        </ns0:nvSpPr>
+        <ns0:spPr>
           <a:xfrm>
             <a:off x="609600" y="4499908"/>
-            <a:ext cx="3333750" cy="400050"/>
+            <a:ext cx="5295900" cy="400050"/>
           </a:xfrm>
           <a:prstGeom prst="rect">
             <a:avLst/>
@@ -10390,8 +10136,8 @@
           <a:ln w="0">
             <a:noFill/>
           </a:ln>
-        </p:spPr>
-        <p:txBody>
+        </ns0:spPr>
+        <ns0:txBody>
           <a:bodyPr wrap="square" lIns="0" tIns="0" rIns="0" bIns="0" anchor="t"/>
           <a:lstStyle/>
           <a:p>
@@ -10407,29 +10153,29 @@
                 <a:ea typeface="Arial"/>
                 <a:cs typeface="Arial"/>
               </a:rPr>
-              <a:t>Directly commercial supply or service provision.</a:t>
+              <a:t>Lower threshold: a few listings can already suggest commercial supply.</a:t>
             </a:r>
           </a:p>
-        </p:txBody>
-      </p:sp>
-      <p:sp>
-        <p:nvSpPr>
-          <p:cNvPr id="38" name="Example item divider">
-            <a:extLst>
-              <a:ext uri="{FF2B5EF4-FFF2-40B4-BE49-F238E27FC236}">
-                <a16:creationId xmlns:a16="http://schemas.microsoft.com/office/drawing/2014/main" id="{2246B849-9CAA-4CDA-9731-69F8CD0A2366}"/>
-              </a:ext>
-            </a:extLst>
-          </p:cNvPr>
-          <p:cNvSpPr>
-            <a:spLocks noGrp="1"/>
-          </p:cNvSpPr>
-          <p:nvPr/>
-        </p:nvSpPr>
-        <p:spPr>
-          <a:xfrm>
-            <a:off x="4352925" y="3995083"/>
-            <a:ext cx="3333750" cy="9525"/>
+        </ns0:txBody>
+      </ns0:sp>
+      <ns0:sp>
+        <ns0:nvSpPr>
+          <ns0:cNvPr id="38" name="Example item divider">
+            <a:extLst>
+              <a:ext uri="{FF2B5EF4-FFF2-40B4-BE49-F238E27FC236}">
+                <ns2:creationId id="{2246B849-9CAA-4CDA-9731-69F8CD0A2366}"/>
+              </a:ext>
+            </a:extLst>
+          </ns0:cNvPr>
+          <ns0:cNvSpPr>
+            <a:spLocks noGrp="1"/>
+          </ns0:cNvSpPr>
+          <ns0:nvPr/>
+        </ns0:nvSpPr>
+        <ns0:spPr>
+          <a:xfrm>
+            <a:off x="6504300" y="3995083"/>
+            <a:ext cx="5295900" cy="9525"/>
           </a:xfrm>
           <a:prstGeom prst="line">
             <a:avLst/>
@@ -10439,33 +10185,33 @@
               <a:srgbClr val="1C1C1C"/>
             </a:solidFill>
           </a:ln>
-        </p:spPr>
-        <p:txBody>
+        </ns0:spPr>
+        <ns0:txBody>
           <a:bodyPr/>
           <a:lstStyle/>
           <a:p>
             <a:endParaRPr/>
           </a:p>
-        </p:txBody>
-      </p:sp>
-      <p:sp>
-        <p:nvSpPr>
-          <p:cNvPr id="39" name="Example categories">
-            <a:extLst>
-              <a:ext uri="{FF2B5EF4-FFF2-40B4-BE49-F238E27FC236}">
-                <a16:creationId xmlns:a16="http://schemas.microsoft.com/office/drawing/2014/main" id="{05E1252A-3BA3-47D5-A31B-89A38C20CC26}"/>
-              </a:ext>
-            </a:extLst>
-          </p:cNvPr>
-          <p:cNvSpPr>
-            <a:spLocks noGrp="1"/>
-          </p:cNvSpPr>
-          <p:nvPr/>
-        </p:nvSpPr>
-        <p:spPr>
-          <a:xfrm>
-            <a:off x="4352925" y="4080808"/>
-            <a:ext cx="3333750" cy="400050"/>
+        </ns0:txBody>
+      </ns0:sp>
+      <ns0:sp>
+        <ns0:nvSpPr>
+          <ns0:cNvPr id="39" name="Example categories">
+            <a:extLst>
+              <a:ext uri="{FF2B5EF4-FFF2-40B4-BE49-F238E27FC236}">
+                <ns2:creationId id="{05E1252A-3BA3-47D5-A31B-89A38C20CC26}"/>
+              </a:ext>
+            </a:extLst>
+          </ns0:cNvPr>
+          <ns0:cNvSpPr>
+            <a:spLocks noGrp="1"/>
+          </ns0:cNvSpPr>
+          <ns0:nvPr/>
+        </ns0:nvSpPr>
+        <ns0:spPr>
+          <a:xfrm>
+            <a:off x="6504300" y="4080808"/>
+            <a:ext cx="5295900" cy="400050"/>
           </a:xfrm>
           <a:prstGeom prst="rect">
             <a:avLst/>
@@ -10474,8 +10220,8 @@
           <a:ln w="0">
             <a:noFill/>
           </a:ln>
-        </p:spPr>
-        <p:txBody>
+        </ns0:spPr>
+        <ns0:txBody>
           <a:bodyPr wrap="square" lIns="0" tIns="0" rIns="0" bIns="0" anchor="t"/>
           <a:lstStyle/>
           <a:p>
@@ -10483,37 +10229,48 @@
               <a:buNone/>
             </a:pPr>
             <a:r>
-              <a:rPr sz="1000">
-                <a:solidFill>
-                  <a:srgbClr val="A5A5A5"/>
+              <a:rPr sz="1000" b="1">
+                <a:solidFill>
+                  <a:srgbClr val="F3F4F6"/>
                 </a:solidFill>
                 <a:latin typeface="Arial"/>
                 <a:ea typeface="Arial"/>
                 <a:cs typeface="Arial"/>
               </a:rPr>
-              <a:t>Jobs</a:t>
+              <a:t>Service / business</a:t>
             </a:r>
-          </a:p>
-        </p:txBody>
-      </p:sp>
-      <p:sp>
-        <p:nvSpPr>
-          <p:cNvPr id="40" name="Example why">
-            <a:extLst>
-              <a:ext uri="{FF2B5EF4-FFF2-40B4-BE49-F238E27FC236}">
-                <a16:creationId xmlns:a16="http://schemas.microsoft.com/office/drawing/2014/main" id="{68867B21-8782-4DF8-8880-22929423EB02}"/>
-              </a:ext>
-            </a:extLst>
-          </p:cNvPr>
-          <p:cNvSpPr>
-            <a:spLocks noGrp="1"/>
-          </p:cNvSpPr>
-          <p:nvPr/>
-        </p:nvSpPr>
-        <p:spPr>
-          <a:xfrm>
-            <a:off x="4352925" y="4499908"/>
-            <a:ext cx="3333750" cy="400050"/>
+            <a:r>
+              <a:rPr sz="1000" b="0">
+                <a:solidFill>
+                  <a:srgbClr val="A7A7A7"/>
+                </a:solidFill>
+                <a:latin typeface="Arial"/>
+                <a:ea typeface="Arial"/>
+                <a:cs typeface="Arial"/>
+              </a:rPr>
+              <a:t>: Business Goods; Services and Tradespeople; Jobs</a:t>
+            </a:r>
+          </a:p>
+        </ns0:txBody>
+      </ns0:sp>
+      <ns0:sp>
+        <ns0:nvSpPr>
+          <ns0:cNvPr id="40" name="Example why">
+            <a:extLst>
+              <a:ext uri="{FF2B5EF4-FFF2-40B4-BE49-F238E27FC236}">
+                <ns2:creationId id="{68867B21-8782-4DF8-8880-22929423EB02}"/>
+              </a:ext>
+            </a:extLst>
+          </ns0:cNvPr>
+          <ns0:cNvSpPr>
+            <a:spLocks noGrp="1"/>
+          </ns0:cNvSpPr>
+          <ns0:nvPr/>
+        </ns0:nvSpPr>
+        <ns0:spPr>
+          <a:xfrm>
+            <a:off x="6504300" y="4499908"/>
+            <a:ext cx="5295900" cy="400050"/>
           </a:xfrm>
           <a:prstGeom prst="rect">
             <a:avLst/>
@@ -10522,8 +10279,8 @@
           <a:ln w="0">
             <a:noFill/>
           </a:ln>
-        </p:spPr>
-        <p:txBody>
+        </ns0:spPr>
+        <ns0:txBody>
           <a:bodyPr wrap="square" lIns="0" tIns="0" rIns="0" bIns="0" anchor="t"/>
           <a:lstStyle/>
           <a:p>
@@ -10539,29 +10296,29 @@
                 <a:ea typeface="Arial"/>
                 <a:cs typeface="Arial"/>
               </a:rPr>
-              <a:t>Usually posted by employers, recruiters, or staffing businesses.</a:t>
+              <a:t>Lower threshold: the category itself is closer to business activity.</a:t>
             </a:r>
           </a:p>
-        </p:txBody>
-      </p:sp>
-      <p:sp>
-        <p:nvSpPr>
-          <p:cNvPr id="41" name="Example item divider">
-            <a:extLst>
-              <a:ext uri="{FF2B5EF4-FFF2-40B4-BE49-F238E27FC236}">
-                <a16:creationId xmlns:a16="http://schemas.microsoft.com/office/drawing/2014/main" id="{46290ABC-8BFD-49DD-91E3-CB896903A01E}"/>
-              </a:ext>
-            </a:extLst>
-          </p:cNvPr>
-          <p:cNvSpPr>
-            <a:spLocks noGrp="1"/>
-          </p:cNvSpPr>
-          <p:nvPr/>
-        </p:nvSpPr>
-        <p:spPr>
-          <a:xfrm>
-            <a:off x="8096250" y="3995083"/>
-            <a:ext cx="3333750" cy="9525"/>
+        </ns0:txBody>
+      </ns0:sp>
+      <ns0:sp>
+        <ns0:nvSpPr>
+          <ns0:cNvPr id="41" name="Example item divider">
+            <a:extLst>
+              <a:ext uri="{FF2B5EF4-FFF2-40B4-BE49-F238E27FC236}">
+                <ns2:creationId id="{46290ABC-8BFD-49DD-91E3-CB896903A01E}"/>
+              </a:ext>
+            </a:extLst>
+          </ns0:cNvPr>
+          <ns0:cNvSpPr>
+            <a:spLocks noGrp="1"/>
+          </ns0:cNvSpPr>
+          <ns0:nvPr/>
+        </ns0:nvSpPr>
+        <ns0:spPr>
+          <a:xfrm>
+            <a:off x="609600" y="4899958"/>
+            <a:ext cx="5295900" cy="9525"/>
           </a:xfrm>
           <a:prstGeom prst="line">
             <a:avLst/>
@@ -10571,33 +10328,33 @@
               <a:srgbClr val="1C1C1C"/>
             </a:solidFill>
           </a:ln>
-        </p:spPr>
-        <p:txBody>
+        </ns0:spPr>
+        <ns0:txBody>
           <a:bodyPr/>
           <a:lstStyle/>
           <a:p>
             <a:endParaRPr/>
           </a:p>
-        </p:txBody>
-      </p:sp>
-      <p:sp>
-        <p:nvSpPr>
-          <p:cNvPr id="42" name="Example categories">
-            <a:extLst>
-              <a:ext uri="{FF2B5EF4-FFF2-40B4-BE49-F238E27FC236}">
-                <a16:creationId xmlns:a16="http://schemas.microsoft.com/office/drawing/2014/main" id="{81EB442F-FC8F-40E9-8077-ABF9D2585C70}"/>
-              </a:ext>
-            </a:extLst>
-          </p:cNvPr>
-          <p:cNvSpPr>
-            <a:spLocks noGrp="1"/>
-          </p:cNvSpPr>
-          <p:nvPr/>
-        </p:nvSpPr>
-        <p:spPr>
-          <a:xfrm>
-            <a:off x="8096250" y="4080808"/>
-            <a:ext cx="3333750" cy="400050"/>
+        </ns0:txBody>
+      </ns0:sp>
+      <ns0:sp>
+        <ns0:nvSpPr>
+          <ns0:cNvPr id="42" name="Example categories">
+            <a:extLst>
+              <a:ext uri="{FF2B5EF4-FFF2-40B4-BE49-F238E27FC236}">
+                <ns2:creationId id="{81EB442F-FC8F-40E9-8077-ABF9D2585C70}"/>
+              </a:ext>
+            </a:extLst>
+          </ns0:cNvPr>
+          <ns0:cNvSpPr>
+            <a:spLocks noGrp="1"/>
+          </ns0:cNvSpPr>
+          <ns0:nvPr/>
+        </ns0:nvSpPr>
+        <ns0:spPr>
+          <a:xfrm>
+            <a:off x="609600" y="4985683"/>
+            <a:ext cx="5295900" cy="400050"/>
           </a:xfrm>
           <a:prstGeom prst="rect">
             <a:avLst/>
@@ -10606,8 +10363,8 @@
           <a:ln w="0">
             <a:noFill/>
           </a:ln>
-        </p:spPr>
-        <p:txBody>
+        </ns0:spPr>
+        <ns0:txBody>
           <a:bodyPr wrap="square" lIns="0" tIns="0" rIns="0" bIns="0" anchor="t"/>
           <a:lstStyle/>
           <a:p>
@@ -10615,37 +10372,48 @@
               <a:buNone/>
             </a:pPr>
             <a:r>
-              <a:rPr sz="1000">
-                <a:solidFill>
-                  <a:srgbClr val="A5A5A5"/>
+              <a:rPr sz="1000" b="1">
+                <a:solidFill>
+                  <a:srgbClr val="F3F4F6"/>
                 </a:solidFill>
                 <a:latin typeface="Arial"/>
                 <a:ea typeface="Arial"/>
                 <a:cs typeface="Arial"/>
               </a:rPr>
-              <a:t>Cars; Miscellaneous Cars; Car Parts; Motorcycles; Caravans and Camping; Water Sports and Boats</a:t>
+              <a:t>Consumer resale</a:t>
             </a:r>
-          </a:p>
-        </p:txBody>
-      </p:sp>
-      <p:sp>
-        <p:nvSpPr>
-          <p:cNvPr id="43" name="Example why">
-            <a:extLst>
-              <a:ext uri="{FF2B5EF4-FFF2-40B4-BE49-F238E27FC236}">
-                <a16:creationId xmlns:a16="http://schemas.microsoft.com/office/drawing/2014/main" id="{F4F683C7-B8B2-495B-9A05-8AE2430F2B8D}"/>
-              </a:ext>
-            </a:extLst>
-          </p:cNvPr>
-          <p:cNvSpPr>
-            <a:spLocks noGrp="1"/>
-          </p:cNvSpPr>
-          <p:nvPr/>
-        </p:nvSpPr>
-        <p:spPr>
-          <a:xfrm>
-            <a:off x="8096250" y="4499908"/>
-            <a:ext cx="3333750" cy="400050"/>
+            <a:r>
+              <a:rPr sz="1000" b="0">
+                <a:solidFill>
+                  <a:srgbClr val="A7A7A7"/>
+                </a:solidFill>
+                <a:latin typeface="Arial"/>
+                <a:ea typeface="Arial"/>
+                <a:cs typeface="Arial"/>
+              </a:rPr>
+              <a:t>: Clothing - Women; Clothing - Men; Books; Children and Babies; CDs and DVDs; Games</a:t>
+            </a:r>
+          </a:p>
+        </ns0:txBody>
+      </ns0:sp>
+      <ns0:sp>
+        <ns0:nvSpPr>
+          <ns0:cNvPr id="43" name="Example why">
+            <a:extLst>
+              <a:ext uri="{FF2B5EF4-FFF2-40B4-BE49-F238E27FC236}">
+                <ns2:creationId id="{F4F683C7-B8B2-495B-9A05-8AE2430F2B8D}"/>
+              </a:ext>
+            </a:extLst>
+          </ns0:cNvPr>
+          <ns0:cNvSpPr>
+            <a:spLocks noGrp="1"/>
+          </ns0:cNvSpPr>
+          <ns0:nvPr/>
+        </ns0:nvSpPr>
+        <ns0:spPr>
+          <a:xfrm>
+            <a:off x="609600" y="5404783"/>
+            <a:ext cx="5295900" cy="400050"/>
           </a:xfrm>
           <a:prstGeom prst="rect">
             <a:avLst/>
@@ -10654,8 +10422,8 @@
           <a:ln w="0">
             <a:noFill/>
           </a:ln>
-        </p:spPr>
-        <p:txBody>
+        </ns0:spPr>
+        <ns0:txBody>
           <a:bodyPr wrap="square" lIns="0" tIns="0" rIns="0" bIns="0" anchor="t"/>
           <a:lstStyle/>
           <a:p>
@@ -10671,29 +10439,29 @@
                 <a:ea typeface="Arial"/>
                 <a:cs typeface="Arial"/>
               </a:rPr>
-              <a:t>High-value inventory and specialist dealers are common.</a:t>
+              <a:t>Higher threshold: several listings can still be normal household selling.</a:t>
             </a:r>
           </a:p>
-        </p:txBody>
-      </p:sp>
-      <p:sp>
-        <p:nvSpPr>
-          <p:cNvPr id="44" name="Example item divider">
-            <a:extLst>
-              <a:ext uri="{FF2B5EF4-FFF2-40B4-BE49-F238E27FC236}">
-                <a16:creationId xmlns:a16="http://schemas.microsoft.com/office/drawing/2014/main" id="{270BFA4F-4A2C-451F-878F-365194EE9BFD}"/>
-              </a:ext>
-            </a:extLst>
-          </p:cNvPr>
-          <p:cNvSpPr>
-            <a:spLocks noGrp="1"/>
-          </p:cNvSpPr>
-          <p:nvPr/>
-        </p:nvSpPr>
-        <p:spPr>
-          <a:xfrm>
-            <a:off x="609600" y="4899958"/>
-            <a:ext cx="3333750" cy="9525"/>
+        </ns0:txBody>
+      </ns0:sp>
+      <ns0:sp>
+        <ns0:nvSpPr>
+          <ns0:cNvPr id="44" name="Example item divider">
+            <a:extLst>
+              <a:ext uri="{FF2B5EF4-FFF2-40B4-BE49-F238E27FC236}">
+                <ns2:creationId id="{270BFA4F-4A2C-451F-878F-365194EE9BFD}"/>
+              </a:ext>
+            </a:extLst>
+          </ns0:cNvPr>
+          <ns0:cNvSpPr>
+            <a:spLocks noGrp="1"/>
+          </ns0:cNvSpPr>
+          <ns0:nvPr/>
+        </ns0:nvSpPr>
+        <ns0:spPr>
+          <a:xfrm>
+            <a:off x="6504300" y="4899958"/>
+            <a:ext cx="5295900" cy="9525"/>
           </a:xfrm>
           <a:prstGeom prst="line">
             <a:avLst/>
@@ -10703,33 +10471,33 @@
               <a:srgbClr val="1C1C1C"/>
             </a:solidFill>
           </a:ln>
-        </p:spPr>
-        <p:txBody>
+        </ns0:spPr>
+        <ns0:txBody>
           <a:bodyPr/>
           <a:lstStyle/>
           <a:p>
             <a:endParaRPr/>
           </a:p>
-        </p:txBody>
-      </p:sp>
-      <p:sp>
-        <p:nvSpPr>
-          <p:cNvPr id="45" name="Example categories">
-            <a:extLst>
-              <a:ext uri="{FF2B5EF4-FFF2-40B4-BE49-F238E27FC236}">
-                <a16:creationId xmlns:a16="http://schemas.microsoft.com/office/drawing/2014/main" id="{E7993DFD-C6D0-4236-B790-67BBBC329E2F}"/>
-              </a:ext>
-            </a:extLst>
-          </p:cNvPr>
-          <p:cNvSpPr>
-            <a:spLocks noGrp="1"/>
-          </p:cNvSpPr>
-          <p:nvPr/>
-        </p:nvSpPr>
-        <p:spPr>
-          <a:xfrm>
-            <a:off x="609600" y="4985683"/>
-            <a:ext cx="3333750" cy="400050"/>
+        </ns0:txBody>
+      </ns0:sp>
+      <ns0:sp>
+        <ns0:nvSpPr>
+          <ns0:cNvPr id="45" name="Example categories">
+            <a:extLst>
+              <a:ext uri="{FF2B5EF4-FFF2-40B4-BE49-F238E27FC236}">
+                <ns2:creationId id="{E7993DFD-C6D0-4236-B790-67BBBC329E2F}"/>
+              </a:ext>
+            </a:extLst>
+          </ns0:cNvPr>
+          <ns0:cNvSpPr>
+            <a:spLocks noGrp="1"/>
+          </ns0:cNvSpPr>
+          <ns0:nvPr/>
+        </ns0:nvSpPr>
+        <ns0:spPr>
+          <a:xfrm>
+            <a:off x="6504300" y="4985683"/>
+            <a:ext cx="5295900" cy="400050"/>
           </a:xfrm>
           <a:prstGeom prst="rect">
             <a:avLst/>
@@ -10738,8 +10506,8 @@
           <a:ln w="0">
             <a:noFill/>
           </a:ln>
-        </p:spPr>
-        <p:txBody>
+        </ns0:spPr>
+        <ns0:txBody>
           <a:bodyPr wrap="square" lIns="0" tIns="0" rIns="0" bIns="0" anchor="t"/>
           <a:lstStyle/>
           <a:p>
@@ -10747,37 +10515,48 @@
               <a:buNone/>
             </a:pPr>
             <a:r>
-              <a:rPr sz="1000">
-                <a:solidFill>
-                  <a:srgbClr val="A5A5A5"/>
+              <a:rPr sz="1000" b="1">
+                <a:solidFill>
+                  <a:srgbClr val="F3F4F6"/>
                 </a:solidFill>
                 <a:latin typeface="Arial"/>
                 <a:ea typeface="Arial"/>
                 <a:cs typeface="Arial"/>
               </a:rPr>
-              <a:t>Homes - Rental; Houses and Rooms; Vacation</a:t>
+              <a:t>Broad / mixed</a:t>
             </a:r>
-          </a:p>
-        </p:txBody>
-      </p:sp>
-      <p:sp>
-        <p:nvSpPr>
-          <p:cNvPr id="46" name="Example why">
-            <a:extLst>
-              <a:ext uri="{FF2B5EF4-FFF2-40B4-BE49-F238E27FC236}">
-                <a16:creationId xmlns:a16="http://schemas.microsoft.com/office/drawing/2014/main" id="{0B46B18E-296E-4763-8294-A758936DF528}"/>
-              </a:ext>
-            </a:extLst>
-          </p:cNvPr>
-          <p:cNvSpPr>
-            <a:spLocks noGrp="1"/>
-          </p:cNvSpPr>
-          <p:nvPr/>
-        </p:nvSpPr>
-        <p:spPr>
-          <a:xfrm>
-            <a:off x="609600" y="5404783"/>
-            <a:ext cx="3333750" cy="400050"/>
+            <a:r>
+              <a:rPr sz="1000" b="0">
+                <a:solidFill>
+                  <a:srgbClr val="A7A7A7"/>
+                </a:solidFill>
+                <a:latin typeface="Arial"/>
+                <a:ea typeface="Arial"/>
+                <a:cs typeface="Arial"/>
+              </a:rPr>
+              <a:t>: Miscellaneous; Home and Furnishings; Garden and Terrace; Hobby and Leisure; Collectibles</a:t>
+            </a:r>
+          </a:p>
+        </ns0:txBody>
+      </ns0:sp>
+      <ns0:sp>
+        <ns0:nvSpPr>
+          <ns0:cNvPr id="46" name="Example why">
+            <a:extLst>
+              <a:ext uri="{FF2B5EF4-FFF2-40B4-BE49-F238E27FC236}">
+                <ns2:creationId id="{0B46B18E-296E-4763-8294-A758936DF528}"/>
+              </a:ext>
+            </a:extLst>
+          </ns0:cNvPr>
+          <ns0:cNvSpPr>
+            <a:spLocks noGrp="1"/>
+          </ns0:cNvSpPr>
+          <ns0:nvPr/>
+        </ns0:nvSpPr>
+        <ns0:spPr>
+          <a:xfrm>
+            <a:off x="6504300" y="5404783"/>
+            <a:ext cx="5295900" cy="400050"/>
           </a:xfrm>
           <a:prstGeom prst="rect">
             <a:avLst/>
@@ -10786,8 +10565,8 @@
           <a:ln w="0">
             <a:noFill/>
           </a:ln>
-        </p:spPr>
-        <p:txBody>
+        </ns0:spPr>
+        <ns0:txBody>
           <a:bodyPr wrap="square" lIns="0" tIns="0" rIns="0" bIns="0" anchor="t"/>
           <a:lstStyle/>
           <a:p>
@@ -10803,286 +10582,22 @@
                 <a:ea typeface="Arial"/>
                 <a:cs typeface="Arial"/>
               </a:rPr>
-              <a:t>Repeated listings often indicate landlords, agencies, or rental operators.</a:t>
+              <a:t>Higher threshold or require another signal, because category alone is noisy.</a:t>
             </a:r>
           </a:p>
-        </p:txBody>
-      </p:sp>
-      <p:sp>
-        <p:nvSpPr>
-          <p:cNvPr id="47" name="Example item divider">
-            <a:extLst>
-              <a:ext uri="{FF2B5EF4-FFF2-40B4-BE49-F238E27FC236}">
-                <a16:creationId xmlns:a16="http://schemas.microsoft.com/office/drawing/2014/main" id="{A5924663-D2BA-408A-B6F2-5152499490F7}"/>
-              </a:ext>
-            </a:extLst>
-          </p:cNvPr>
-          <p:cNvSpPr>
-            <a:spLocks noGrp="1"/>
-          </p:cNvSpPr>
-          <p:nvPr/>
-        </p:nvSpPr>
-        <p:spPr>
-          <a:xfrm>
-            <a:off x="4352925" y="4899958"/>
-            <a:ext cx="3333750" cy="9525"/>
-          </a:xfrm>
-          <a:prstGeom prst="line">
-            <a:avLst/>
-          </a:prstGeom>
-          <a:ln w="9525">
-            <a:solidFill>
-              <a:srgbClr val="1C1C1C"/>
-            </a:solidFill>
-          </a:ln>
-        </p:spPr>
-        <p:txBody>
-          <a:bodyPr/>
-          <a:lstStyle/>
-          <a:p>
-            <a:endParaRPr/>
-          </a:p>
-        </p:txBody>
-      </p:sp>
-      <p:sp>
-        <p:nvSpPr>
-          <p:cNvPr id="48" name="Example categories">
-            <a:extLst>
-              <a:ext uri="{FF2B5EF4-FFF2-40B4-BE49-F238E27FC236}">
-                <a16:creationId xmlns:a16="http://schemas.microsoft.com/office/drawing/2014/main" id="{0D00C058-A644-42D7-B48E-4755D16D5594}"/>
-              </a:ext>
-            </a:extLst>
-          </p:cNvPr>
-          <p:cNvSpPr>
-            <a:spLocks noGrp="1"/>
-          </p:cNvSpPr>
-          <p:nvPr/>
-        </p:nvSpPr>
-        <p:spPr>
-          <a:xfrm>
-            <a:off x="4352925" y="4985683"/>
-            <a:ext cx="3333750" cy="400050"/>
-          </a:xfrm>
-          <a:prstGeom prst="rect">
-            <a:avLst/>
-          </a:prstGeom>
-          <a:noFill/>
-          <a:ln w="0">
-            <a:noFill/>
-          </a:ln>
-        </p:spPr>
-        <p:txBody>
-          <a:bodyPr wrap="square" lIns="0" tIns="0" rIns="0" bIns="0" anchor="t"/>
-          <a:lstStyle/>
-          <a:p>
-            <a:pPr marL="0" indent="0">
-              <a:buNone/>
-            </a:pPr>
-            <a:r>
-              <a:rPr sz="1000">
-                <a:solidFill>
-                  <a:srgbClr val="A5A5A5"/>
-                </a:solidFill>
-                <a:latin typeface="Arial"/>
-                <a:ea typeface="Arial"/>
-                <a:cs typeface="Arial"/>
-              </a:rPr>
-              <a:t>DIY and Renovation; Garden and Terrace; Home and Furnishings; White Goods and Appliances</a:t>
-            </a:r>
-          </a:p>
-        </p:txBody>
-      </p:sp>
-      <p:sp>
-        <p:nvSpPr>
-          <p:cNvPr id="49" name="Example why">
-            <a:extLst>
-              <a:ext uri="{FF2B5EF4-FFF2-40B4-BE49-F238E27FC236}">
-                <a16:creationId xmlns:a16="http://schemas.microsoft.com/office/drawing/2014/main" id="{94764D63-01EB-423D-B9FB-A8BAB35E8FFA}"/>
-              </a:ext>
-            </a:extLst>
-          </p:cNvPr>
-          <p:cNvSpPr>
-            <a:spLocks noGrp="1"/>
-          </p:cNvSpPr>
-          <p:nvPr/>
-        </p:nvSpPr>
-        <p:spPr>
-          <a:xfrm>
-            <a:off x="4352925" y="5404783"/>
-            <a:ext cx="3333750" cy="400050"/>
-          </a:xfrm>
-          <a:prstGeom prst="rect">
-            <a:avLst/>
-          </a:prstGeom>
-          <a:noFill/>
-          <a:ln w="0">
-            <a:noFill/>
-          </a:ln>
-        </p:spPr>
-        <p:txBody>
-          <a:bodyPr wrap="square" lIns="0" tIns="0" rIns="0" bIns="0" anchor="t"/>
-          <a:lstStyle/>
-          <a:p>
-            <a:pPr marL="0" indent="0">
-              <a:buNone/>
-            </a:pPr>
-            <a:r>
-              <a:rPr sz="1200" b="1">
-                <a:solidFill>
-                  <a:srgbClr val="F3F4F6"/>
-                </a:solidFill>
-                <a:latin typeface="Arial"/>
-                <a:ea typeface="Arial"/>
-                <a:cs typeface="Arial"/>
-              </a:rPr>
-              <a:t>Repeated supply suggests trades, refurbishers, or retail-like sellers.</a:t>
-            </a:r>
-          </a:p>
-        </p:txBody>
-      </p:sp>
-      <p:sp>
-        <p:nvSpPr>
-          <p:cNvPr id="50" name="Example item divider">
-            <a:extLst>
-              <a:ext uri="{FF2B5EF4-FFF2-40B4-BE49-F238E27FC236}">
-                <a16:creationId xmlns:a16="http://schemas.microsoft.com/office/drawing/2014/main" id="{1334D0ED-AEF6-430D-AAD4-887FB1777183}"/>
-              </a:ext>
-            </a:extLst>
-          </p:cNvPr>
-          <p:cNvSpPr>
-            <a:spLocks noGrp="1"/>
-          </p:cNvSpPr>
-          <p:nvPr/>
-        </p:nvSpPr>
-        <p:spPr>
-          <a:xfrm>
-            <a:off x="8096250" y="4899958"/>
-            <a:ext cx="3333750" cy="9525"/>
-          </a:xfrm>
-          <a:prstGeom prst="line">
-            <a:avLst/>
-          </a:prstGeom>
-          <a:ln w="9525">
-            <a:solidFill>
-              <a:srgbClr val="1C1C1C"/>
-            </a:solidFill>
-          </a:ln>
-        </p:spPr>
-        <p:txBody>
-          <a:bodyPr/>
-          <a:lstStyle/>
-          <a:p>
-            <a:endParaRPr/>
-          </a:p>
-        </p:txBody>
-      </p:sp>
-      <p:sp>
-        <p:nvSpPr>
-          <p:cNvPr id="51" name="Example categories">
-            <a:extLst>
-              <a:ext uri="{FF2B5EF4-FFF2-40B4-BE49-F238E27FC236}">
-                <a16:creationId xmlns:a16="http://schemas.microsoft.com/office/drawing/2014/main" id="{A86E22DA-7935-4DD0-B484-CCE1B8A94D0A}"/>
-              </a:ext>
-            </a:extLst>
-          </p:cNvPr>
-          <p:cNvSpPr>
-            <a:spLocks noGrp="1"/>
-          </p:cNvSpPr>
-          <p:nvPr/>
-        </p:nvSpPr>
-        <p:spPr>
-          <a:xfrm>
-            <a:off x="8096250" y="4985683"/>
-            <a:ext cx="3333750" cy="400050"/>
-          </a:xfrm>
-          <a:prstGeom prst="rect">
-            <a:avLst/>
-          </a:prstGeom>
-          <a:noFill/>
-          <a:ln w="0">
-            <a:noFill/>
-          </a:ln>
-        </p:spPr>
-        <p:txBody>
-          <a:bodyPr wrap="square" lIns="0" tIns="0" rIns="0" bIns="0" anchor="t"/>
-          <a:lstStyle/>
-          <a:p>
-            <a:pPr marL="0" indent="0">
-              <a:buNone/>
-            </a:pPr>
-            <a:r>
-              <a:rPr sz="1000">
-                <a:solidFill>
-                  <a:srgbClr val="A5A5A5"/>
-                </a:solidFill>
-                <a:latin typeface="Arial"/>
-                <a:ea typeface="Arial"/>
-                <a:cs typeface="Arial"/>
-              </a:rPr>
-              <a:t>Computers and Software; Telecommunications</a:t>
-            </a:r>
-          </a:p>
-        </p:txBody>
-      </p:sp>
-      <p:sp>
-        <p:nvSpPr>
-          <p:cNvPr id="52" name="Example why">
-            <a:extLst>
-              <a:ext uri="{FF2B5EF4-FFF2-40B4-BE49-F238E27FC236}">
-                <a16:creationId xmlns:a16="http://schemas.microsoft.com/office/drawing/2014/main" id="{F2F5919C-3E07-4504-B583-903A719166AB}"/>
-              </a:ext>
-            </a:extLst>
-          </p:cNvPr>
-          <p:cNvSpPr>
-            <a:spLocks noGrp="1"/>
-          </p:cNvSpPr>
-          <p:nvPr/>
-        </p:nvSpPr>
-        <p:spPr>
-          <a:xfrm>
-            <a:off x="8096250" y="5404783"/>
-            <a:ext cx="3333750" cy="400050"/>
-          </a:xfrm>
-          <a:prstGeom prst="rect">
-            <a:avLst/>
-          </a:prstGeom>
-          <a:noFill/>
-          <a:ln w="0">
-            <a:noFill/>
-          </a:ln>
-        </p:spPr>
-        <p:txBody>
-          <a:bodyPr wrap="square" lIns="0" tIns="0" rIns="0" bIns="0" anchor="t"/>
-          <a:lstStyle/>
-          <a:p>
-            <a:pPr marL="0" indent="0">
-              <a:buNone/>
-            </a:pPr>
-            <a:r>
-              <a:rPr sz="1200" b="1">
-                <a:solidFill>
-                  <a:srgbClr val="F3F4F6"/>
-                </a:solidFill>
-                <a:latin typeface="Arial"/>
-                <a:ea typeface="Arial"/>
-                <a:cs typeface="Arial"/>
-              </a:rPr>
-              <a:t>Repeated listings often indicate resellers or repair/retail activity.</a:t>
-            </a:r>
-          </a:p>
-        </p:txBody>
-      </p:sp>
-    </p:spTree>
-    <p:extLst>
-      <p:ext uri="{BB962C8B-B14F-4D97-AF65-F5344CB8AC3E}">
-        <p14:creationId xmlns:p14="http://schemas.microsoft.com/office/powerpoint/2010/main" val="1630150295"/>
-      </p:ext>
-    </p:extLst>
-  </p:cSld>
-  <p:clrMapOvr>
+        </ns0:txBody>
+      </ns0:sp>
+    </ns0:spTree>
+    <ns0:extLst>
+      <ns0:ext uri="{BB962C8B-B14F-4D97-AF65-F5344CB8AC3E}">
+        <ns3:creationId val="1630150295"/>
+      </ns0:ext>
+    </ns0:extLst>
+  </ns0:cSld>
+  <ns0:clrMapOvr>
     <a:masterClrMapping/>
-  </p:clrMapOvr>
-</p:sld>
+  </ns0:clrMapOvr>
+</ns0:sld>
 </file>
 
 <file path=ppt/slides/slide7.xml><?xml version="1.0" encoding="utf-8"?>

</xml_diff>